<commit_message>
Consolidate project notebook and refresh deliverables
Co-authored-by: Copilot <223556219+Copilot@users.noreply.github.com>
</commit_message>
<xml_diff>
--- a/report/project_presentation.pptx
+++ b/report/project_presentation.pptx
@@ -5,23 +5,23 @@
     <p:sldMasterId id="2147483648" r:id="rId1"/>
   </p:sldMasterIdLst>
   <p:sldIdLst>
-    <p:sldId id="256" r:id="rId7"/>
-    <p:sldId id="257" r:id="rId8"/>
-    <p:sldId id="258" r:id="rId9"/>
-    <p:sldId id="259" r:id="rId10"/>
-    <p:sldId id="260" r:id="rId11"/>
-    <p:sldId id="261" r:id="rId12"/>
-    <p:sldId id="262" r:id="rId13"/>
-    <p:sldId id="263" r:id="rId14"/>
-    <p:sldId id="264" r:id="rId15"/>
-    <p:sldId id="265" r:id="rId16"/>
-    <p:sldId id="266" r:id="rId17"/>
-    <p:sldId id="267" r:id="rId18"/>
-    <p:sldId id="268" r:id="rId19"/>
-    <p:sldId id="269" r:id="rId20"/>
-    <p:sldId id="270" r:id="rId21"/>
+    <p:sldId id="256" r:id="rId2"/>
+    <p:sldId id="257" r:id="rId3"/>
+    <p:sldId id="258" r:id="rId4"/>
+    <p:sldId id="259" r:id="rId5"/>
+    <p:sldId id="260" r:id="rId6"/>
+    <p:sldId id="261" r:id="rId7"/>
+    <p:sldId id="262" r:id="rId8"/>
+    <p:sldId id="263" r:id="rId9"/>
+    <p:sldId id="264" r:id="rId10"/>
+    <p:sldId id="265" r:id="rId11"/>
+    <p:sldId id="266" r:id="rId12"/>
+    <p:sldId id="267" r:id="rId13"/>
+    <p:sldId id="268" r:id="rId14"/>
+    <p:sldId id="269" r:id="rId15"/>
+    <p:sldId id="270" r:id="rId16"/>
   </p:sldIdLst>
-  <p:sldSz cx="12191695" cy="6858000" type="screen4x3"/>
+  <p:sldSz cx="12192000" cy="6858000"/>
   <p:notesSz cx="6858000" cy="9144000"/>
   <p:defaultTextStyle>
     <a:defPPr>
@@ -118,6 +118,22 @@
       </a:defRPr>
     </a:lvl9pPr>
   </p:defaultTextStyle>
+  <p:extLst>
+    <p:ext uri="{EFAFB233-063F-42B5-8137-9DF3F51BA10A}">
+      <p15:sldGuideLst xmlns:p15="http://schemas.microsoft.com/office/powerpoint/2012/main">
+        <p15:guide id="1" orient="horz" pos="2160">
+          <p15:clr>
+            <a:srgbClr val="A4A3A4"/>
+          </p15:clr>
+        </p15:guide>
+        <p15:guide id="2" pos="2880">
+          <p15:clr>
+            <a:srgbClr val="A4A3A4"/>
+          </p15:clr>
+        </p15:guide>
+      </p15:sldGuideLst>
+    </p:ext>
+  </p:extLst>
 </p:presentation>
 </file>
 
@@ -159,10 +175,9 @@
           <a:lstStyle/>
           <a:p>
             <a:r>
-              <a:rPr lang="en-US" smtClean="0"/>
+              <a:rPr lang="en-US"/>
               <a:t>Click to edit Master title style</a:t>
             </a:r>
-            <a:endParaRPr lang="en-US"/>
           </a:p>
         </p:txBody>
       </p:sp>
@@ -278,10 +293,9 @@
           </a:lstStyle>
           <a:p>
             <a:r>
-              <a:rPr lang="en-US" smtClean="0"/>
+              <a:rPr lang="en-US"/>
               <a:t>Click to edit Master subtitle style</a:t>
             </a:r>
-            <a:endParaRPr lang="en-US"/>
           </a:p>
         </p:txBody>
       </p:sp>
@@ -302,7 +316,7 @@
           <a:p>
             <a:fld id="{5BCAD085-E8A6-8845-BD4E-CB4CCA059FC4}" type="datetimeFigureOut">
               <a:rPr lang="en-US" smtClean="0"/>
-              <a:t>1/27/13</a:t>
+              <a:t>10/13/2026</a:t>
             </a:fld>
             <a:endParaRPr lang="en-US"/>
           </a:p>
@@ -396,10 +410,9 @@
           <a:lstStyle/>
           <a:p>
             <a:r>
-              <a:rPr lang="en-US" smtClean="0"/>
+              <a:rPr lang="en-US"/>
               <a:t>Click to edit Master title style</a:t>
             </a:r>
-            <a:endParaRPr lang="en-US"/>
           </a:p>
         </p:txBody>
       </p:sp>
@@ -420,38 +433,37 @@
           <a:p>
             <a:pPr lvl="0"/>
             <a:r>
-              <a:rPr lang="en-US" smtClean="0"/>
+              <a:rPr lang="en-US"/>
               <a:t>Click to edit Master text styles</a:t>
             </a:r>
           </a:p>
           <a:p>
             <a:pPr lvl="1"/>
             <a:r>
-              <a:rPr lang="en-US" smtClean="0"/>
+              <a:rPr lang="en-US"/>
               <a:t>Second level</a:t>
             </a:r>
           </a:p>
           <a:p>
             <a:pPr lvl="2"/>
             <a:r>
-              <a:rPr lang="en-US" smtClean="0"/>
+              <a:rPr lang="en-US"/>
               <a:t>Third level</a:t>
             </a:r>
           </a:p>
           <a:p>
             <a:pPr lvl="3"/>
             <a:r>
-              <a:rPr lang="en-US" smtClean="0"/>
+              <a:rPr lang="en-US"/>
               <a:t>Fourth level</a:t>
             </a:r>
           </a:p>
           <a:p>
             <a:pPr lvl="4"/>
             <a:r>
-              <a:rPr lang="en-US" smtClean="0"/>
+              <a:rPr lang="en-US"/>
               <a:t>Fifth level</a:t>
             </a:r>
-            <a:endParaRPr lang="en-US"/>
           </a:p>
         </p:txBody>
       </p:sp>
@@ -472,7 +484,7 @@
           <a:p>
             <a:fld id="{5BCAD085-E8A6-8845-BD4E-CB4CCA059FC4}" type="datetimeFigureOut">
               <a:rPr lang="en-US" smtClean="0"/>
-              <a:t>1/27/13</a:t>
+              <a:t>10/13/2026</a:t>
             </a:fld>
             <a:endParaRPr lang="en-US"/>
           </a:p>
@@ -571,10 +583,9 @@
           <a:lstStyle/>
           <a:p>
             <a:r>
-              <a:rPr lang="en-US" smtClean="0"/>
+              <a:rPr lang="en-US"/>
               <a:t>Click to edit Master title style</a:t>
             </a:r>
-            <a:endParaRPr lang="en-US"/>
           </a:p>
         </p:txBody>
       </p:sp>
@@ -600,38 +611,37 @@
           <a:p>
             <a:pPr lvl="0"/>
             <a:r>
-              <a:rPr lang="en-US" smtClean="0"/>
+              <a:rPr lang="en-US"/>
               <a:t>Click to edit Master text styles</a:t>
             </a:r>
           </a:p>
           <a:p>
             <a:pPr lvl="1"/>
             <a:r>
-              <a:rPr lang="en-US" smtClean="0"/>
+              <a:rPr lang="en-US"/>
               <a:t>Second level</a:t>
             </a:r>
           </a:p>
           <a:p>
             <a:pPr lvl="2"/>
             <a:r>
-              <a:rPr lang="en-US" smtClean="0"/>
+              <a:rPr lang="en-US"/>
               <a:t>Third level</a:t>
             </a:r>
           </a:p>
           <a:p>
             <a:pPr lvl="3"/>
             <a:r>
-              <a:rPr lang="en-US" smtClean="0"/>
+              <a:rPr lang="en-US"/>
               <a:t>Fourth level</a:t>
             </a:r>
           </a:p>
           <a:p>
             <a:pPr lvl="4"/>
             <a:r>
-              <a:rPr lang="en-US" smtClean="0"/>
+              <a:rPr lang="en-US"/>
               <a:t>Fifth level</a:t>
             </a:r>
-            <a:endParaRPr lang="en-US"/>
           </a:p>
         </p:txBody>
       </p:sp>
@@ -652,7 +662,7 @@
           <a:p>
             <a:fld id="{5BCAD085-E8A6-8845-BD4E-CB4CCA059FC4}" type="datetimeFigureOut">
               <a:rPr lang="en-US" smtClean="0"/>
-              <a:t>1/27/13</a:t>
+              <a:t>10/13/2026</a:t>
             </a:fld>
             <a:endParaRPr lang="en-US"/>
           </a:p>
@@ -746,10 +756,9 @@
           <a:lstStyle/>
           <a:p>
             <a:r>
-              <a:rPr lang="en-US" smtClean="0"/>
+              <a:rPr lang="en-US"/>
               <a:t>Click to edit Master title style</a:t>
             </a:r>
-            <a:endParaRPr lang="en-US"/>
           </a:p>
         </p:txBody>
       </p:sp>
@@ -770,38 +779,37 @@
           <a:p>
             <a:pPr lvl="0"/>
             <a:r>
-              <a:rPr lang="en-US" smtClean="0"/>
+              <a:rPr lang="en-US"/>
               <a:t>Click to edit Master text styles</a:t>
             </a:r>
           </a:p>
           <a:p>
             <a:pPr lvl="1"/>
             <a:r>
-              <a:rPr lang="en-US" smtClean="0"/>
+              <a:rPr lang="en-US"/>
               <a:t>Second level</a:t>
             </a:r>
           </a:p>
           <a:p>
             <a:pPr lvl="2"/>
             <a:r>
-              <a:rPr lang="en-US" smtClean="0"/>
+              <a:rPr lang="en-US"/>
               <a:t>Third level</a:t>
             </a:r>
           </a:p>
           <a:p>
             <a:pPr lvl="3"/>
             <a:r>
-              <a:rPr lang="en-US" smtClean="0"/>
+              <a:rPr lang="en-US"/>
               <a:t>Fourth level</a:t>
             </a:r>
           </a:p>
           <a:p>
             <a:pPr lvl="4"/>
             <a:r>
-              <a:rPr lang="en-US" smtClean="0"/>
+              <a:rPr lang="en-US"/>
               <a:t>Fifth level</a:t>
             </a:r>
-            <a:endParaRPr lang="en-US"/>
           </a:p>
         </p:txBody>
       </p:sp>
@@ -822,7 +830,7 @@
           <a:p>
             <a:fld id="{5BCAD085-E8A6-8845-BD4E-CB4CCA059FC4}" type="datetimeFigureOut">
               <a:rPr lang="en-US" smtClean="0"/>
-              <a:t>1/27/13</a:t>
+              <a:t>10/13/2026</a:t>
             </a:fld>
             <a:endParaRPr lang="en-US"/>
           </a:p>
@@ -925,10 +933,9 @@
           </a:lstStyle>
           <a:p>
             <a:r>
-              <a:rPr lang="en-US" smtClean="0"/>
+              <a:rPr lang="en-US"/>
               <a:t>Click to edit Master title style</a:t>
             </a:r>
-            <a:endParaRPr lang="en-US"/>
           </a:p>
         </p:txBody>
       </p:sp>
@@ -1045,7 +1052,7 @@
           <a:p>
             <a:pPr lvl="0"/>
             <a:r>
-              <a:rPr lang="en-US" smtClean="0"/>
+              <a:rPr lang="en-US"/>
               <a:t>Click to edit Master text styles</a:t>
             </a:r>
           </a:p>
@@ -1068,7 +1075,7 @@
           <a:p>
             <a:fld id="{5BCAD085-E8A6-8845-BD4E-CB4CCA059FC4}" type="datetimeFigureOut">
               <a:rPr lang="en-US" smtClean="0"/>
-              <a:t>1/27/13</a:t>
+              <a:t>10/13/2026</a:t>
             </a:fld>
             <a:endParaRPr lang="en-US"/>
           </a:p>
@@ -1162,10 +1169,9 @@
           <a:lstStyle/>
           <a:p>
             <a:r>
-              <a:rPr lang="en-US" smtClean="0"/>
+              <a:rPr lang="en-US"/>
               <a:t>Click to edit Master title style</a:t>
             </a:r>
-            <a:endParaRPr lang="en-US"/>
           </a:p>
         </p:txBody>
       </p:sp>
@@ -1219,38 +1225,37 @@
           <a:p>
             <a:pPr lvl="0"/>
             <a:r>
-              <a:rPr lang="en-US" smtClean="0"/>
+              <a:rPr lang="en-US"/>
               <a:t>Click to edit Master text styles</a:t>
             </a:r>
           </a:p>
           <a:p>
             <a:pPr lvl="1"/>
             <a:r>
-              <a:rPr lang="en-US" smtClean="0"/>
+              <a:rPr lang="en-US"/>
               <a:t>Second level</a:t>
             </a:r>
           </a:p>
           <a:p>
             <a:pPr lvl="2"/>
             <a:r>
-              <a:rPr lang="en-US" smtClean="0"/>
+              <a:rPr lang="en-US"/>
               <a:t>Third level</a:t>
             </a:r>
           </a:p>
           <a:p>
             <a:pPr lvl="3"/>
             <a:r>
-              <a:rPr lang="en-US" smtClean="0"/>
+              <a:rPr lang="en-US"/>
               <a:t>Fourth level</a:t>
             </a:r>
           </a:p>
           <a:p>
             <a:pPr lvl="4"/>
             <a:r>
-              <a:rPr lang="en-US" smtClean="0"/>
+              <a:rPr lang="en-US"/>
               <a:t>Fifth level</a:t>
             </a:r>
-            <a:endParaRPr lang="en-US"/>
           </a:p>
         </p:txBody>
       </p:sp>
@@ -1304,38 +1309,37 @@
           <a:p>
             <a:pPr lvl="0"/>
             <a:r>
-              <a:rPr lang="en-US" smtClean="0"/>
+              <a:rPr lang="en-US"/>
               <a:t>Click to edit Master text styles</a:t>
             </a:r>
           </a:p>
           <a:p>
             <a:pPr lvl="1"/>
             <a:r>
-              <a:rPr lang="en-US" smtClean="0"/>
+              <a:rPr lang="en-US"/>
               <a:t>Second level</a:t>
             </a:r>
           </a:p>
           <a:p>
             <a:pPr lvl="2"/>
             <a:r>
-              <a:rPr lang="en-US" smtClean="0"/>
+              <a:rPr lang="en-US"/>
               <a:t>Third level</a:t>
             </a:r>
           </a:p>
           <a:p>
             <a:pPr lvl="3"/>
             <a:r>
-              <a:rPr lang="en-US" smtClean="0"/>
+              <a:rPr lang="en-US"/>
               <a:t>Fourth level</a:t>
             </a:r>
           </a:p>
           <a:p>
             <a:pPr lvl="4"/>
             <a:r>
-              <a:rPr lang="en-US" smtClean="0"/>
+              <a:rPr lang="en-US"/>
               <a:t>Fifth level</a:t>
             </a:r>
-            <a:endParaRPr lang="en-US"/>
           </a:p>
         </p:txBody>
       </p:sp>
@@ -1356,7 +1360,7 @@
           <a:p>
             <a:fld id="{5BCAD085-E8A6-8845-BD4E-CB4CCA059FC4}" type="datetimeFigureOut">
               <a:rPr lang="en-US" smtClean="0"/>
-              <a:t>1/27/13</a:t>
+              <a:t>10/13/2026</a:t>
             </a:fld>
             <a:endParaRPr lang="en-US"/>
           </a:p>
@@ -1454,10 +1458,9 @@
           </a:lstStyle>
           <a:p>
             <a:r>
-              <a:rPr lang="en-US" smtClean="0"/>
+              <a:rPr lang="en-US"/>
               <a:t>Click to edit Master title style</a:t>
             </a:r>
-            <a:endParaRPr lang="en-US"/>
           </a:p>
         </p:txBody>
       </p:sp>
@@ -1520,7 +1523,7 @@
           <a:p>
             <a:pPr lvl="0"/>
             <a:r>
-              <a:rPr lang="en-US" smtClean="0"/>
+              <a:rPr lang="en-US"/>
               <a:t>Click to edit Master text styles</a:t>
             </a:r>
           </a:p>
@@ -1576,38 +1579,37 @@
           <a:p>
             <a:pPr lvl="0"/>
             <a:r>
-              <a:rPr lang="en-US" smtClean="0"/>
+              <a:rPr lang="en-US"/>
               <a:t>Click to edit Master text styles</a:t>
             </a:r>
           </a:p>
           <a:p>
             <a:pPr lvl="1"/>
             <a:r>
-              <a:rPr lang="en-US" smtClean="0"/>
+              <a:rPr lang="en-US"/>
               <a:t>Second level</a:t>
             </a:r>
           </a:p>
           <a:p>
             <a:pPr lvl="2"/>
             <a:r>
-              <a:rPr lang="en-US" smtClean="0"/>
+              <a:rPr lang="en-US"/>
               <a:t>Third level</a:t>
             </a:r>
           </a:p>
           <a:p>
             <a:pPr lvl="3"/>
             <a:r>
-              <a:rPr lang="en-US" smtClean="0"/>
+              <a:rPr lang="en-US"/>
               <a:t>Fourth level</a:t>
             </a:r>
           </a:p>
           <a:p>
             <a:pPr lvl="4"/>
             <a:r>
-              <a:rPr lang="en-US" smtClean="0"/>
+              <a:rPr lang="en-US"/>
               <a:t>Fifth level</a:t>
             </a:r>
-            <a:endParaRPr lang="en-US"/>
           </a:p>
         </p:txBody>
       </p:sp>
@@ -1670,7 +1672,7 @@
           <a:p>
             <a:pPr lvl="0"/>
             <a:r>
-              <a:rPr lang="en-US" smtClean="0"/>
+              <a:rPr lang="en-US"/>
               <a:t>Click to edit Master text styles</a:t>
             </a:r>
           </a:p>
@@ -1726,38 +1728,37 @@
           <a:p>
             <a:pPr lvl="0"/>
             <a:r>
-              <a:rPr lang="en-US" smtClean="0"/>
+              <a:rPr lang="en-US"/>
               <a:t>Click to edit Master text styles</a:t>
             </a:r>
           </a:p>
           <a:p>
             <a:pPr lvl="1"/>
             <a:r>
-              <a:rPr lang="en-US" smtClean="0"/>
+              <a:rPr lang="en-US"/>
               <a:t>Second level</a:t>
             </a:r>
           </a:p>
           <a:p>
             <a:pPr lvl="2"/>
             <a:r>
-              <a:rPr lang="en-US" smtClean="0"/>
+              <a:rPr lang="en-US"/>
               <a:t>Third level</a:t>
             </a:r>
           </a:p>
           <a:p>
             <a:pPr lvl="3"/>
             <a:r>
-              <a:rPr lang="en-US" smtClean="0"/>
+              <a:rPr lang="en-US"/>
               <a:t>Fourth level</a:t>
             </a:r>
           </a:p>
           <a:p>
             <a:pPr lvl="4"/>
             <a:r>
-              <a:rPr lang="en-US" smtClean="0"/>
+              <a:rPr lang="en-US"/>
               <a:t>Fifth level</a:t>
             </a:r>
-            <a:endParaRPr lang="en-US"/>
           </a:p>
         </p:txBody>
       </p:sp>
@@ -1778,7 +1779,7 @@
           <a:p>
             <a:fld id="{5BCAD085-E8A6-8845-BD4E-CB4CCA059FC4}" type="datetimeFigureOut">
               <a:rPr lang="en-US" smtClean="0"/>
-              <a:t>1/27/13</a:t>
+              <a:t>10/13/2026</a:t>
             </a:fld>
             <a:endParaRPr lang="en-US"/>
           </a:p>
@@ -1872,10 +1873,9 @@
           <a:lstStyle/>
           <a:p>
             <a:r>
-              <a:rPr lang="en-US" smtClean="0"/>
+              <a:rPr lang="en-US"/>
               <a:t>Click to edit Master title style</a:t>
             </a:r>
-            <a:endParaRPr lang="en-US"/>
           </a:p>
         </p:txBody>
       </p:sp>
@@ -1896,7 +1896,7 @@
           <a:p>
             <a:fld id="{5BCAD085-E8A6-8845-BD4E-CB4CCA059FC4}" type="datetimeFigureOut">
               <a:rPr lang="en-US" smtClean="0"/>
-              <a:t>1/27/13</a:t>
+              <a:t>10/13/2026</a:t>
             </a:fld>
             <a:endParaRPr lang="en-US"/>
           </a:p>
@@ -1991,7 +1991,7 @@
           <a:p>
             <a:fld id="{5BCAD085-E8A6-8845-BD4E-CB4CCA059FC4}" type="datetimeFigureOut">
               <a:rPr lang="en-US" smtClean="0"/>
-              <a:t>1/27/13</a:t>
+              <a:t>10/13/2026</a:t>
             </a:fld>
             <a:endParaRPr lang="en-US"/>
           </a:p>
@@ -2094,10 +2094,9 @@
           </a:lstStyle>
           <a:p>
             <a:r>
-              <a:rPr lang="en-US" smtClean="0"/>
+              <a:rPr lang="en-US"/>
               <a:t>Click to edit Master title style</a:t>
             </a:r>
-            <a:endParaRPr lang="en-US"/>
           </a:p>
         </p:txBody>
       </p:sp>
@@ -2151,38 +2150,37 @@
           <a:p>
             <a:pPr lvl="0"/>
             <a:r>
-              <a:rPr lang="en-US" smtClean="0"/>
+              <a:rPr lang="en-US"/>
               <a:t>Click to edit Master text styles</a:t>
             </a:r>
           </a:p>
           <a:p>
             <a:pPr lvl="1"/>
             <a:r>
-              <a:rPr lang="en-US" smtClean="0"/>
+              <a:rPr lang="en-US"/>
               <a:t>Second level</a:t>
             </a:r>
           </a:p>
           <a:p>
             <a:pPr lvl="2"/>
             <a:r>
-              <a:rPr lang="en-US" smtClean="0"/>
+              <a:rPr lang="en-US"/>
               <a:t>Third level</a:t>
             </a:r>
           </a:p>
           <a:p>
             <a:pPr lvl="3"/>
             <a:r>
-              <a:rPr lang="en-US" smtClean="0"/>
+              <a:rPr lang="en-US"/>
               <a:t>Fourth level</a:t>
             </a:r>
           </a:p>
           <a:p>
             <a:pPr lvl="4"/>
             <a:r>
-              <a:rPr lang="en-US" smtClean="0"/>
+              <a:rPr lang="en-US"/>
               <a:t>Fifth level</a:t>
             </a:r>
-            <a:endParaRPr lang="en-US"/>
           </a:p>
         </p:txBody>
       </p:sp>
@@ -2245,7 +2243,7 @@
           <a:p>
             <a:pPr lvl="0"/>
             <a:r>
-              <a:rPr lang="en-US" smtClean="0"/>
+              <a:rPr lang="en-US"/>
               <a:t>Click to edit Master text styles</a:t>
             </a:r>
           </a:p>
@@ -2268,7 +2266,7 @@
           <a:p>
             <a:fld id="{5BCAD085-E8A6-8845-BD4E-CB4CCA059FC4}" type="datetimeFigureOut">
               <a:rPr lang="en-US" smtClean="0"/>
-              <a:t>1/27/13</a:t>
+              <a:t>10/13/2026</a:t>
             </a:fld>
             <a:endParaRPr lang="en-US"/>
           </a:p>
@@ -2371,10 +2369,9 @@
           </a:lstStyle>
           <a:p>
             <a:r>
-              <a:rPr lang="en-US" smtClean="0"/>
+              <a:rPr lang="en-US"/>
               <a:t>Click to edit Master title style</a:t>
             </a:r>
-            <a:endParaRPr lang="en-US"/>
           </a:p>
         </p:txBody>
       </p:sp>
@@ -2498,7 +2495,7 @@
           <a:p>
             <a:pPr lvl="0"/>
             <a:r>
-              <a:rPr lang="en-US" smtClean="0"/>
+              <a:rPr lang="en-US"/>
               <a:t>Click to edit Master text styles</a:t>
             </a:r>
           </a:p>
@@ -2521,7 +2518,7 @@
           <a:p>
             <a:fld id="{5BCAD085-E8A6-8845-BD4E-CB4CCA059FC4}" type="datetimeFigureOut">
               <a:rPr lang="en-US" smtClean="0"/>
-              <a:t>1/27/13</a:t>
+              <a:t>10/13/2026</a:t>
             </a:fld>
             <a:endParaRPr lang="en-US"/>
           </a:p>
@@ -2630,10 +2627,9 @@
           <a:lstStyle/>
           <a:p>
             <a:r>
-              <a:rPr lang="en-US" smtClean="0"/>
+              <a:rPr lang="en-US"/>
               <a:t>Click to edit Master title style</a:t>
             </a:r>
-            <a:endParaRPr lang="en-US"/>
           </a:p>
         </p:txBody>
       </p:sp>
@@ -2664,38 +2660,37 @@
           <a:p>
             <a:pPr lvl="0"/>
             <a:r>
-              <a:rPr lang="en-US" smtClean="0"/>
+              <a:rPr lang="en-US"/>
               <a:t>Click to edit Master text styles</a:t>
             </a:r>
           </a:p>
           <a:p>
             <a:pPr lvl="1"/>
             <a:r>
-              <a:rPr lang="en-US" smtClean="0"/>
+              <a:rPr lang="en-US"/>
               <a:t>Second level</a:t>
             </a:r>
           </a:p>
           <a:p>
             <a:pPr lvl="2"/>
             <a:r>
-              <a:rPr lang="en-US" smtClean="0"/>
+              <a:rPr lang="en-US"/>
               <a:t>Third level</a:t>
             </a:r>
           </a:p>
           <a:p>
             <a:pPr lvl="3"/>
             <a:r>
-              <a:rPr lang="en-US" smtClean="0"/>
+              <a:rPr lang="en-US"/>
               <a:t>Fourth level</a:t>
             </a:r>
           </a:p>
           <a:p>
             <a:pPr lvl="4"/>
             <a:r>
-              <a:rPr lang="en-US" smtClean="0"/>
+              <a:rPr lang="en-US"/>
               <a:t>Fifth level</a:t>
             </a:r>
-            <a:endParaRPr lang="en-US"/>
           </a:p>
         </p:txBody>
       </p:sp>
@@ -2734,7 +2729,7 @@
           <a:p>
             <a:fld id="{5BCAD085-E8A6-8845-BD4E-CB4CCA059FC4}" type="datetimeFigureOut">
               <a:rPr lang="en-US" smtClean="0"/>
-              <a:t>1/27/13</a:t>
+              <a:t>10/13/2026</a:t>
             </a:fld>
             <a:endParaRPr lang="en-US"/>
           </a:p>
@@ -3093,7 +3088,7 @@
 </file>
 
 <file path=ppt/slides/slide1.xml><?xml version="1.0" encoding="utf-8"?>
-<p:sld xmlns:a="http://schemas.openxmlformats.org/drawingml/2006/main" xmlns:p="http://schemas.openxmlformats.org/presentationml/2006/main" xmlns:r="http://schemas.openxmlformats.org/officeDocument/2006/relationships">
+<p:sld xmlns:a="http://schemas.openxmlformats.org/drawingml/2006/main" xmlns:r="http://schemas.openxmlformats.org/officeDocument/2006/relationships" xmlns:p="http://schemas.openxmlformats.org/presentationml/2006/main">
   <p:cSld>
     <p:bg>
       <p:bgPr>
@@ -3109,7 +3104,14 @@
         <p:cNvGrpSpPr/>
         <p:nvPr/>
       </p:nvGrpSpPr>
-      <p:grpSpPr/>
+      <p:grpSpPr>
+        <a:xfrm>
+          <a:off x="0" y="0"/>
+          <a:ext cx="0" cy="0"/>
+          <a:chOff x="0" y="0"/>
+          <a:chExt cx="0" cy="0"/>
+        </a:xfrm>
+      </p:grpSpPr>
       <p:sp>
         <p:nvSpPr>
           <p:cNvPr id="2" name="Oval 1"/>
@@ -3118,8 +3120,8 @@
         </p:nvSpPr>
         <p:spPr>
           <a:xfrm>
-            <a:off x="8641080" y="-1188720"/>
-            <a:ext cx="4572000" cy="4572000"/>
+            <a:off x="8110728" y="9144"/>
+            <a:ext cx="3593592" cy="3858768"/>
           </a:xfrm>
           <a:prstGeom prst="ellipse">
             <a:avLst/>
@@ -3152,6 +3154,7 @@
           <a:lstStyle/>
           <a:p>
             <a:pPr algn="ctr"/>
+            <a:endParaRPr/>
           </a:p>
         </p:txBody>
       </p:sp>
@@ -3163,7 +3166,7 @@
         </p:nvSpPr>
         <p:spPr>
           <a:xfrm>
-            <a:off x="9509760" y="-457200"/>
+            <a:off x="8494776" y="306325"/>
             <a:ext cx="2926080" cy="2926080"/>
           </a:xfrm>
           <a:prstGeom prst="ellipse">
@@ -3197,6 +3200,7 @@
           <a:lstStyle/>
           <a:p>
             <a:pPr algn="ctr"/>
+            <a:endParaRPr/>
           </a:p>
         </p:txBody>
       </p:sp>
@@ -3217,7 +3221,7 @@
           <a:noFill/>
         </p:spPr>
         <p:txBody>
-          <a:bodyPr wrap="square" lIns="36576" rIns="36576" tIns="36576" bIns="36576" anchor="t">
+          <a:bodyPr wrap="square" lIns="36576" tIns="36576" rIns="36576" bIns="36576" anchor="t">
             <a:spAutoFit/>
           </a:bodyPr>
           <a:lstStyle/>
@@ -3247,7 +3251,7 @@
         </p:nvSpPr>
         <p:spPr>
           <a:xfrm>
-            <a:off x="822960" y="1417320"/>
+            <a:off x="771144" y="1069848"/>
             <a:ext cx="9418320" cy="1234440"/>
           </a:xfrm>
           <a:prstGeom prst="rect">
@@ -3256,7 +3260,7 @@
           <a:noFill/>
         </p:spPr>
         <p:txBody>
-          <a:bodyPr wrap="square" lIns="36576" rIns="36576" tIns="36576" bIns="36576" anchor="t">
+          <a:bodyPr wrap="square" lIns="36576" tIns="36576" rIns="36576" bIns="36576" anchor="t">
             <a:spAutoFit/>
           </a:bodyPr>
           <a:lstStyle/>
@@ -3273,6 +3277,7 @@
               </a:defRPr>
             </a:pPr>
             <a:r>
+              <a:rPr dirty="0"/>
               <a:t>From Voice to Text</a:t>
             </a:r>
           </a:p>
@@ -3289,6 +3294,7 @@
               </a:defRPr>
             </a:pPr>
             <a:r>
+              <a:rPr dirty="0"/>
               <a:t>and Back</a:t>
             </a:r>
           </a:p>
@@ -3302,16 +3308,16 @@
         </p:nvSpPr>
         <p:spPr>
           <a:xfrm>
-            <a:off x="868680" y="2743200"/>
-            <a:ext cx="7955279" cy="640080"/>
-          </a:xfrm>
-          <a:prstGeom prst="rect">
-            <a:avLst/>
-          </a:prstGeom>
-          <a:noFill/>
-        </p:spPr>
-        <p:txBody>
-          <a:bodyPr wrap="square" lIns="36576" rIns="36576" tIns="36576" bIns="36576" anchor="t">
+            <a:off x="771144" y="2281429"/>
+            <a:ext cx="7955279" cy="2056460"/>
+          </a:xfrm>
+          <a:prstGeom prst="rect">
+            <a:avLst/>
+          </a:prstGeom>
+          <a:noFill/>
+        </p:spPr>
+        <p:txBody>
+          <a:bodyPr wrap="square" lIns="36576" tIns="36576" rIns="36576" bIns="36576" anchor="t">
             <a:spAutoFit/>
           </a:bodyPr>
           <a:lstStyle/>
@@ -3328,6 +3334,7 @@
               </a:defRPr>
             </a:pPr>
             <a:r>
+              <a:rPr dirty="0"/>
               <a:t>ASR, CTC, WER and text-to-speech analysis</a:t>
             </a:r>
           </a:p>
@@ -3344,8 +3351,84 @@
               </a:defRPr>
             </a:pPr>
             <a:r>
+              <a:rPr dirty="0"/>
               <a:t>of a speech sample with disfluencies</a:t>
             </a:r>
+            <a:endParaRPr lang="en-IN" dirty="0"/>
+          </a:p>
+          <a:p>
+            <a:pPr algn="l">
+              <a:spcAft>
+                <a:spcPts val="500"/>
+              </a:spcAft>
+              <a:defRPr sz="1800" b="0">
+                <a:solidFill>
+                  <a:srgbClr val="D8E8F1"/>
+                </a:solidFill>
+                <a:latin typeface="Aptos"/>
+              </a:defRPr>
+            </a:pPr>
+            <a:endParaRPr lang="en-IN" dirty="0"/>
+          </a:p>
+          <a:p>
+            <a:pPr algn="l">
+              <a:spcAft>
+                <a:spcPts val="500"/>
+              </a:spcAft>
+              <a:defRPr sz="1800" b="0">
+                <a:solidFill>
+                  <a:srgbClr val="D8E8F1"/>
+                </a:solidFill>
+                <a:latin typeface="Aptos"/>
+              </a:defRPr>
+            </a:pPr>
+            <a:r>
+              <a:rPr lang="en-IN" dirty="0"/>
+              <a:t>Presented by ;</a:t>
+            </a:r>
+          </a:p>
+          <a:p>
+            <a:pPr algn="l">
+              <a:spcAft>
+                <a:spcPts val="500"/>
+              </a:spcAft>
+              <a:defRPr sz="1800" b="0">
+                <a:solidFill>
+                  <a:srgbClr val="D8E8F1"/>
+                </a:solidFill>
+                <a:latin typeface="Aptos"/>
+              </a:defRPr>
+            </a:pPr>
+            <a:r>
+              <a:rPr lang="en-IN" dirty="0"/>
+              <a:t>Arijit Das [RA2311003010191]</a:t>
+            </a:r>
+          </a:p>
+          <a:p>
+            <a:pPr algn="l">
+              <a:spcAft>
+                <a:spcPts val="500"/>
+              </a:spcAft>
+              <a:defRPr sz="1800" b="0">
+                <a:solidFill>
+                  <a:srgbClr val="D8E8F1"/>
+                </a:solidFill>
+                <a:latin typeface="Aptos"/>
+              </a:defRPr>
+            </a:pPr>
+            <a:r>
+              <a:rPr lang="en-IN" dirty="0"/>
+              <a:t>Spandan </a:t>
+            </a:r>
+            <a:r>
+              <a:rPr lang="en-IN" dirty="0" err="1"/>
+              <a:t>Duari</a:t>
+            </a:r>
+            <a:r>
+              <a:rPr lang="en-IN"/>
+              <a:t> [RA2311003010207]</a:t>
+            </a:r>
+            <a:endParaRPr dirty="0"/>
           </a:p>
         </p:txBody>
       </p:sp>
@@ -3357,7 +3440,7 @@
         </p:nvSpPr>
         <p:spPr>
           <a:xfrm>
-            <a:off x="594360" y="3977639"/>
+            <a:off x="411480" y="4594862"/>
             <a:ext cx="2029968" cy="914400"/>
           </a:xfrm>
           <a:prstGeom prst="roundRect">
@@ -3393,6 +3476,7 @@
           <a:lstStyle/>
           <a:p>
             <a:pPr algn="ctr"/>
+            <a:endParaRPr/>
           </a:p>
         </p:txBody>
       </p:sp>
@@ -3404,7 +3488,7 @@
         </p:nvSpPr>
         <p:spPr>
           <a:xfrm>
-            <a:off x="685800" y="4160520"/>
+            <a:off x="502920" y="4777743"/>
             <a:ext cx="1847088" cy="274320"/>
           </a:xfrm>
           <a:prstGeom prst="rect">
@@ -3413,7 +3497,7 @@
           <a:noFill/>
         </p:spPr>
         <p:txBody>
-          <a:bodyPr wrap="square" lIns="36576" rIns="36576" tIns="36576" bIns="36576" anchor="t">
+          <a:bodyPr wrap="square" lIns="36576" tIns="36576" rIns="36576" bIns="36576" anchor="t">
             <a:spAutoFit/>
           </a:bodyPr>
           <a:lstStyle/>
@@ -3443,7 +3527,7 @@
         </p:nvSpPr>
         <p:spPr>
           <a:xfrm>
-            <a:off x="685800" y="4498848"/>
+            <a:off x="502920" y="5116071"/>
             <a:ext cx="1847088" cy="219456"/>
           </a:xfrm>
           <a:prstGeom prst="rect">
@@ -3452,7 +3536,7 @@
           <a:noFill/>
         </p:spPr>
         <p:txBody>
-          <a:bodyPr wrap="square" lIns="36576" rIns="36576" tIns="36576" bIns="36576" anchor="t">
+          <a:bodyPr wrap="square" lIns="36576" tIns="36576" rIns="36576" bIns="36576" anchor="t">
             <a:spAutoFit/>
           </a:bodyPr>
           <a:lstStyle/>
@@ -3482,7 +3566,7 @@
         </p:nvSpPr>
         <p:spPr>
           <a:xfrm>
-            <a:off x="2624328" y="4279392"/>
+            <a:off x="2441448" y="4896615"/>
             <a:ext cx="310896" cy="228600"/>
           </a:xfrm>
           <a:prstGeom prst="rect">
@@ -3491,7 +3575,7 @@
           <a:noFill/>
         </p:spPr>
         <p:txBody>
-          <a:bodyPr wrap="square" lIns="36576" rIns="36576" tIns="36576" bIns="36576" anchor="t">
+          <a:bodyPr wrap="square" lIns="36576" tIns="36576" rIns="36576" bIns="36576" anchor="t">
             <a:spAutoFit/>
           </a:bodyPr>
           <a:lstStyle/>
@@ -3521,7 +3605,7 @@
         </p:nvSpPr>
         <p:spPr>
           <a:xfrm>
-            <a:off x="2935224" y="3977639"/>
+            <a:off x="2752344" y="4594862"/>
             <a:ext cx="2029968" cy="914400"/>
           </a:xfrm>
           <a:prstGeom prst="roundRect">
@@ -3557,6 +3641,7 @@
           <a:lstStyle/>
           <a:p>
             <a:pPr algn="ctr"/>
+            <a:endParaRPr/>
           </a:p>
         </p:txBody>
       </p:sp>
@@ -3568,7 +3653,7 @@
         </p:nvSpPr>
         <p:spPr>
           <a:xfrm>
-            <a:off x="3026664" y="4160520"/>
+            <a:off x="2843784" y="4777743"/>
             <a:ext cx="1847088" cy="274320"/>
           </a:xfrm>
           <a:prstGeom prst="rect">
@@ -3577,7 +3662,7 @@
           <a:noFill/>
         </p:spPr>
         <p:txBody>
-          <a:bodyPr wrap="square" lIns="36576" rIns="36576" tIns="36576" bIns="36576" anchor="t">
+          <a:bodyPr wrap="square" lIns="36576" tIns="36576" rIns="36576" bIns="36576" anchor="t">
             <a:spAutoFit/>
           </a:bodyPr>
           <a:lstStyle/>
@@ -3607,7 +3692,7 @@
         </p:nvSpPr>
         <p:spPr>
           <a:xfrm>
-            <a:off x="3026664" y="4498848"/>
+            <a:off x="2843784" y="5116071"/>
             <a:ext cx="1847088" cy="219456"/>
           </a:xfrm>
           <a:prstGeom prst="rect">
@@ -3616,7 +3701,7 @@
           <a:noFill/>
         </p:spPr>
         <p:txBody>
-          <a:bodyPr wrap="square" lIns="36576" rIns="36576" tIns="36576" bIns="36576" anchor="t">
+          <a:bodyPr wrap="square" lIns="36576" tIns="36576" rIns="36576" bIns="36576" anchor="t">
             <a:spAutoFit/>
           </a:bodyPr>
           <a:lstStyle/>
@@ -3646,7 +3731,7 @@
         </p:nvSpPr>
         <p:spPr>
           <a:xfrm>
-            <a:off x="4965192" y="4279392"/>
+            <a:off x="4782312" y="4896615"/>
             <a:ext cx="310896" cy="228600"/>
           </a:xfrm>
           <a:prstGeom prst="rect">
@@ -3655,7 +3740,7 @@
           <a:noFill/>
         </p:spPr>
         <p:txBody>
-          <a:bodyPr wrap="square" lIns="36576" rIns="36576" tIns="36576" bIns="36576" anchor="t">
+          <a:bodyPr wrap="square" lIns="36576" tIns="36576" rIns="36576" bIns="36576" anchor="t">
             <a:spAutoFit/>
           </a:bodyPr>
           <a:lstStyle/>
@@ -3685,7 +3770,7 @@
         </p:nvSpPr>
         <p:spPr>
           <a:xfrm>
-            <a:off x="5276088" y="3977639"/>
+            <a:off x="5093208" y="4594862"/>
             <a:ext cx="2029968" cy="914400"/>
           </a:xfrm>
           <a:prstGeom prst="roundRect">
@@ -3721,6 +3806,7 @@
           <a:lstStyle/>
           <a:p>
             <a:pPr algn="ctr"/>
+            <a:endParaRPr/>
           </a:p>
         </p:txBody>
       </p:sp>
@@ -3732,7 +3818,7 @@
         </p:nvSpPr>
         <p:spPr>
           <a:xfrm>
-            <a:off x="5367528" y="4160520"/>
+            <a:off x="5184648" y="4777743"/>
             <a:ext cx="1847088" cy="274320"/>
           </a:xfrm>
           <a:prstGeom prst="rect">
@@ -3741,7 +3827,7 @@
           <a:noFill/>
         </p:spPr>
         <p:txBody>
-          <a:bodyPr wrap="square" lIns="36576" rIns="36576" tIns="36576" bIns="36576" anchor="t">
+          <a:bodyPr wrap="square" lIns="36576" tIns="36576" rIns="36576" bIns="36576" anchor="t">
             <a:spAutoFit/>
           </a:bodyPr>
           <a:lstStyle/>
@@ -3771,7 +3857,7 @@
         </p:nvSpPr>
         <p:spPr>
           <a:xfrm>
-            <a:off x="5367528" y="4498848"/>
+            <a:off x="5184648" y="5116071"/>
             <a:ext cx="1847088" cy="219456"/>
           </a:xfrm>
           <a:prstGeom prst="rect">
@@ -3780,7 +3866,7 @@
           <a:noFill/>
         </p:spPr>
         <p:txBody>
-          <a:bodyPr wrap="square" lIns="36576" rIns="36576" tIns="36576" bIns="36576" anchor="t">
+          <a:bodyPr wrap="square" lIns="36576" tIns="36576" rIns="36576" bIns="36576" anchor="t">
             <a:spAutoFit/>
           </a:bodyPr>
           <a:lstStyle/>
@@ -3810,7 +3896,7 @@
         </p:nvSpPr>
         <p:spPr>
           <a:xfrm>
-            <a:off x="7306056" y="4279392"/>
+            <a:off x="7123176" y="4896615"/>
             <a:ext cx="310896" cy="228600"/>
           </a:xfrm>
           <a:prstGeom prst="rect">
@@ -3819,7 +3905,7 @@
           <a:noFill/>
         </p:spPr>
         <p:txBody>
-          <a:bodyPr wrap="square" lIns="36576" rIns="36576" tIns="36576" bIns="36576" anchor="t">
+          <a:bodyPr wrap="square" lIns="36576" tIns="36576" rIns="36576" bIns="36576" anchor="t">
             <a:spAutoFit/>
           </a:bodyPr>
           <a:lstStyle/>
@@ -3849,7 +3935,7 @@
         </p:nvSpPr>
         <p:spPr>
           <a:xfrm>
-            <a:off x="7616952" y="3977639"/>
+            <a:off x="7434072" y="4594862"/>
             <a:ext cx="2029968" cy="914400"/>
           </a:xfrm>
           <a:prstGeom prst="roundRect">
@@ -3885,6 +3971,7 @@
           <a:lstStyle/>
           <a:p>
             <a:pPr algn="ctr"/>
+            <a:endParaRPr/>
           </a:p>
         </p:txBody>
       </p:sp>
@@ -3896,7 +3983,7 @@
         </p:nvSpPr>
         <p:spPr>
           <a:xfrm>
-            <a:off x="7708392" y="4160520"/>
+            <a:off x="7525512" y="4777743"/>
             <a:ext cx="1847088" cy="274320"/>
           </a:xfrm>
           <a:prstGeom prst="rect">
@@ -3905,7 +3992,7 @@
           <a:noFill/>
         </p:spPr>
         <p:txBody>
-          <a:bodyPr wrap="square" lIns="36576" rIns="36576" tIns="36576" bIns="36576" anchor="t">
+          <a:bodyPr wrap="square" lIns="36576" tIns="36576" rIns="36576" bIns="36576" anchor="t">
             <a:spAutoFit/>
           </a:bodyPr>
           <a:lstStyle/>
@@ -3935,7 +4022,7 @@
         </p:nvSpPr>
         <p:spPr>
           <a:xfrm>
-            <a:off x="7708392" y="4498848"/>
+            <a:off x="7525512" y="5116071"/>
             <a:ext cx="1847088" cy="219456"/>
           </a:xfrm>
           <a:prstGeom prst="rect">
@@ -3944,7 +4031,7 @@
           <a:noFill/>
         </p:spPr>
         <p:txBody>
-          <a:bodyPr wrap="square" lIns="36576" rIns="36576" tIns="36576" bIns="36576" anchor="t">
+          <a:bodyPr wrap="square" lIns="36576" tIns="36576" rIns="36576" bIns="36576" anchor="t">
             <a:spAutoFit/>
           </a:bodyPr>
           <a:lstStyle/>
@@ -3974,7 +4061,7 @@
         </p:nvSpPr>
         <p:spPr>
           <a:xfrm>
-            <a:off x="9646920" y="4279392"/>
+            <a:off x="9464040" y="4896615"/>
             <a:ext cx="310896" cy="228600"/>
           </a:xfrm>
           <a:prstGeom prst="rect">
@@ -3983,7 +4070,7 @@
           <a:noFill/>
         </p:spPr>
         <p:txBody>
-          <a:bodyPr wrap="square" lIns="36576" rIns="36576" tIns="36576" bIns="36576" anchor="t">
+          <a:bodyPr wrap="square" lIns="36576" tIns="36576" rIns="36576" bIns="36576" anchor="t">
             <a:spAutoFit/>
           </a:bodyPr>
           <a:lstStyle/>
@@ -4013,7 +4100,7 @@
         </p:nvSpPr>
         <p:spPr>
           <a:xfrm>
-            <a:off x="9957816" y="3977639"/>
+            <a:off x="9774936" y="4594862"/>
             <a:ext cx="2029968" cy="914400"/>
           </a:xfrm>
           <a:prstGeom prst="roundRect">
@@ -4049,6 +4136,7 @@
           <a:lstStyle/>
           <a:p>
             <a:pPr algn="ctr"/>
+            <a:endParaRPr/>
           </a:p>
         </p:txBody>
       </p:sp>
@@ -4060,7 +4148,7 @@
         </p:nvSpPr>
         <p:spPr>
           <a:xfrm>
-            <a:off x="10049256" y="4160520"/>
+            <a:off x="9866376" y="4777743"/>
             <a:ext cx="1847088" cy="274320"/>
           </a:xfrm>
           <a:prstGeom prst="rect">
@@ -4069,7 +4157,7 @@
           <a:noFill/>
         </p:spPr>
         <p:txBody>
-          <a:bodyPr wrap="square" lIns="36576" rIns="36576" tIns="36576" bIns="36576" anchor="t">
+          <a:bodyPr wrap="square" lIns="36576" tIns="36576" rIns="36576" bIns="36576" anchor="t">
             <a:spAutoFit/>
           </a:bodyPr>
           <a:lstStyle/>
@@ -4099,7 +4187,7 @@
         </p:nvSpPr>
         <p:spPr>
           <a:xfrm>
-            <a:off x="10049256" y="4498848"/>
+            <a:off x="9866376" y="5116071"/>
             <a:ext cx="1847088" cy="219456"/>
           </a:xfrm>
           <a:prstGeom prst="rect">
@@ -4108,7 +4196,7 @@
           <a:noFill/>
         </p:spPr>
         <p:txBody>
-          <a:bodyPr wrap="square" lIns="36576" rIns="36576" tIns="36576" bIns="36576" anchor="t">
+          <a:bodyPr wrap="square" lIns="36576" tIns="36576" rIns="36576" bIns="36576" anchor="t">
             <a:spAutoFit/>
           </a:bodyPr>
           <a:lstStyle/>
@@ -4138,7 +4226,7 @@
         </p:nvSpPr>
         <p:spPr>
           <a:xfrm>
-            <a:off x="868680" y="5349240"/>
+            <a:off x="822960" y="5687569"/>
             <a:ext cx="7955279" cy="502920"/>
           </a:xfrm>
           <a:prstGeom prst="rect">
@@ -4147,7 +4235,7 @@
           <a:noFill/>
         </p:spPr>
         <p:txBody>
-          <a:bodyPr wrap="square" lIns="36576" rIns="36576" tIns="36576" bIns="36576" anchor="t">
+          <a:bodyPr wrap="square" lIns="36576" tIns="36576" rIns="36576" bIns="36576" anchor="t">
             <a:spAutoFit/>
           </a:bodyPr>
           <a:lstStyle/>
@@ -4186,7 +4274,7 @@
           <a:noFill/>
         </p:spPr>
         <p:txBody>
-          <a:bodyPr wrap="square" lIns="36576" rIns="36576" tIns="36576" bIns="36576" anchor="t">
+          <a:bodyPr wrap="square" lIns="36576" tIns="36576" rIns="36576" bIns="36576" anchor="t">
             <a:spAutoFit/>
           </a:bodyPr>
           <a:lstStyle/>
@@ -4225,7 +4313,7 @@
           <a:noFill/>
         </p:spPr>
         <p:txBody>
-          <a:bodyPr wrap="square" lIns="36576" rIns="36576" tIns="36576" bIns="36576" anchor="t">
+          <a:bodyPr wrap="square" lIns="36576" tIns="36576" rIns="36576" bIns="36576" anchor="t">
             <a:spAutoFit/>
           </a:bodyPr>
           <a:lstStyle/>
@@ -4256,7 +4344,7 @@
 </file>
 
 <file path=ppt/slides/slide10.xml><?xml version="1.0" encoding="utf-8"?>
-<p:sld xmlns:a="http://schemas.openxmlformats.org/drawingml/2006/main" xmlns:p="http://schemas.openxmlformats.org/presentationml/2006/main" xmlns:r="http://schemas.openxmlformats.org/officeDocument/2006/relationships">
+<p:sld xmlns:a="http://schemas.openxmlformats.org/drawingml/2006/main" xmlns:r="http://schemas.openxmlformats.org/officeDocument/2006/relationships" xmlns:p="http://schemas.openxmlformats.org/presentationml/2006/main">
   <p:cSld>
     <p:bg>
       <p:bgPr>
@@ -4272,7 +4360,14 @@
         <p:cNvGrpSpPr/>
         <p:nvPr/>
       </p:nvGrpSpPr>
-      <p:grpSpPr/>
+      <p:grpSpPr>
+        <a:xfrm>
+          <a:off x="0" y="0"/>
+          <a:ext cx="0" cy="0"/>
+          <a:chOff x="0" y="0"/>
+          <a:chExt cx="0" cy="0"/>
+        </a:xfrm>
+      </p:grpSpPr>
       <p:sp>
         <p:nvSpPr>
           <p:cNvPr id="2" name="Rectangle 1"/>
@@ -4315,6 +4410,7 @@
           <a:lstStyle/>
           <a:p>
             <a:pPr algn="ctr"/>
+            <a:endParaRPr/>
           </a:p>
         </p:txBody>
       </p:sp>
@@ -4335,7 +4431,7 @@
           <a:noFill/>
         </p:spPr>
         <p:txBody>
-          <a:bodyPr wrap="square" lIns="36576" rIns="36576" tIns="36576" bIns="36576" anchor="t">
+          <a:bodyPr wrap="square" lIns="36576" tIns="36576" rIns="36576" bIns="36576" anchor="t">
             <a:spAutoFit/>
           </a:bodyPr>
           <a:lstStyle/>
@@ -4374,7 +4470,7 @@
           <a:noFill/>
         </p:spPr>
         <p:txBody>
-          <a:bodyPr wrap="square" lIns="36576" rIns="36576" tIns="36576" bIns="36576" anchor="t">
+          <a:bodyPr wrap="square" lIns="36576" tIns="36576" rIns="36576" bIns="36576" anchor="t">
             <a:spAutoFit/>
           </a:bodyPr>
           <a:lstStyle/>
@@ -4438,6 +4534,7 @@
           <a:lstStyle/>
           <a:p>
             <a:pPr algn="ctr"/>
+            <a:endParaRPr/>
           </a:p>
         </p:txBody>
       </p:sp>
@@ -4458,7 +4555,7 @@
           <a:noFill/>
         </p:spPr>
         <p:txBody>
-          <a:bodyPr wrap="square" lIns="36576" rIns="36576" tIns="36576" bIns="36576" anchor="t">
+          <a:bodyPr wrap="square" lIns="36576" tIns="36576" rIns="36576" bIns="36576" anchor="t">
             <a:spAutoFit/>
           </a:bodyPr>
           <a:lstStyle/>
@@ -4497,7 +4594,7 @@
           <a:noFill/>
         </p:spPr>
         <p:txBody>
-          <a:bodyPr wrap="square" lIns="36576" rIns="36576" tIns="36576" bIns="36576" anchor="t">
+          <a:bodyPr wrap="square" lIns="36576" tIns="36576" rIns="36576" bIns="36576" anchor="t">
             <a:spAutoFit/>
           </a:bodyPr>
           <a:lstStyle/>
@@ -4563,6 +4660,7 @@
           <a:lstStyle/>
           <a:p>
             <a:pPr algn="ctr"/>
+            <a:endParaRPr/>
           </a:p>
         </p:txBody>
       </p:sp>
@@ -4583,7 +4681,7 @@
           <a:noFill/>
         </p:spPr>
         <p:txBody>
-          <a:bodyPr wrap="square" lIns="36576" rIns="36576" tIns="36576" bIns="36576" anchor="t">
+          <a:bodyPr wrap="square" lIns="36576" tIns="36576" rIns="36576" bIns="36576" anchor="t">
             <a:spAutoFit/>
           </a:bodyPr>
           <a:lstStyle/>
@@ -4649,6 +4747,7 @@
           <a:lstStyle/>
           <a:p>
             <a:pPr algn="ctr"/>
+            <a:endParaRPr/>
           </a:p>
         </p:txBody>
       </p:sp>
@@ -4694,6 +4793,7 @@
           <a:lstStyle/>
           <a:p>
             <a:pPr algn="ctr"/>
+            <a:endParaRPr/>
           </a:p>
         </p:txBody>
       </p:sp>
@@ -4714,7 +4814,7 @@
           <a:noFill/>
         </p:spPr>
         <p:txBody>
-          <a:bodyPr wrap="square" lIns="36576" rIns="36576" tIns="36576" bIns="36576" anchor="t">
+          <a:bodyPr wrap="square" lIns="36576" tIns="36576" rIns="36576" bIns="36576" anchor="t">
             <a:spAutoFit/>
           </a:bodyPr>
           <a:lstStyle/>
@@ -4753,7 +4853,7 @@
           <a:noFill/>
         </p:spPr>
         <p:txBody>
-          <a:bodyPr wrap="square" lIns="36576" rIns="36576" tIns="36576" bIns="36576" anchor="t">
+          <a:bodyPr wrap="square" lIns="36576" tIns="36576" rIns="36576" bIns="36576" anchor="t">
             <a:spAutoFit/>
           </a:bodyPr>
           <a:lstStyle/>
@@ -4819,6 +4919,7 @@
           <a:lstStyle/>
           <a:p>
             <a:pPr algn="ctr"/>
+            <a:endParaRPr/>
           </a:p>
         </p:txBody>
       </p:sp>
@@ -4864,6 +4965,7 @@
           <a:lstStyle/>
           <a:p>
             <a:pPr algn="ctr"/>
+            <a:endParaRPr/>
           </a:p>
         </p:txBody>
       </p:sp>
@@ -4884,7 +4986,7 @@
           <a:noFill/>
         </p:spPr>
         <p:txBody>
-          <a:bodyPr wrap="square" lIns="36576" rIns="36576" tIns="36576" bIns="36576" anchor="t">
+          <a:bodyPr wrap="square" lIns="36576" tIns="36576" rIns="36576" bIns="36576" anchor="t">
             <a:spAutoFit/>
           </a:bodyPr>
           <a:lstStyle/>
@@ -4923,7 +5025,7 @@
           <a:noFill/>
         </p:spPr>
         <p:txBody>
-          <a:bodyPr wrap="square" lIns="36576" rIns="36576" tIns="36576" bIns="36576" anchor="t">
+          <a:bodyPr wrap="square" lIns="36576" tIns="36576" rIns="36576" bIns="36576" anchor="t">
             <a:spAutoFit/>
           </a:bodyPr>
           <a:lstStyle/>
@@ -4989,6 +5091,7 @@
           <a:lstStyle/>
           <a:p>
             <a:pPr algn="ctr"/>
+            <a:endParaRPr/>
           </a:p>
         </p:txBody>
       </p:sp>
@@ -5034,6 +5137,7 @@
           <a:lstStyle/>
           <a:p>
             <a:pPr algn="ctr"/>
+            <a:endParaRPr/>
           </a:p>
         </p:txBody>
       </p:sp>
@@ -5054,7 +5158,7 @@
           <a:noFill/>
         </p:spPr>
         <p:txBody>
-          <a:bodyPr wrap="square" lIns="36576" rIns="36576" tIns="36576" bIns="36576" anchor="t">
+          <a:bodyPr wrap="square" lIns="36576" tIns="36576" rIns="36576" bIns="36576" anchor="t">
             <a:spAutoFit/>
           </a:bodyPr>
           <a:lstStyle/>
@@ -5093,7 +5197,7 @@
           <a:noFill/>
         </p:spPr>
         <p:txBody>
-          <a:bodyPr wrap="square" lIns="36576" rIns="36576" tIns="36576" bIns="36576" anchor="t">
+          <a:bodyPr wrap="square" lIns="36576" tIns="36576" rIns="36576" bIns="36576" anchor="t">
             <a:spAutoFit/>
           </a:bodyPr>
           <a:lstStyle/>
@@ -5159,6 +5263,7 @@
           <a:lstStyle/>
           <a:p>
             <a:pPr algn="ctr"/>
+            <a:endParaRPr/>
           </a:p>
         </p:txBody>
       </p:sp>
@@ -5204,6 +5309,7 @@
           <a:lstStyle/>
           <a:p>
             <a:pPr algn="ctr"/>
+            <a:endParaRPr/>
           </a:p>
         </p:txBody>
       </p:sp>
@@ -5224,7 +5330,7 @@
           <a:noFill/>
         </p:spPr>
         <p:txBody>
-          <a:bodyPr wrap="square" lIns="36576" rIns="36576" tIns="36576" bIns="36576" anchor="t">
+          <a:bodyPr wrap="square" lIns="36576" tIns="36576" rIns="36576" bIns="36576" anchor="t">
             <a:spAutoFit/>
           </a:bodyPr>
           <a:lstStyle/>
@@ -5263,7 +5369,7 @@
           <a:noFill/>
         </p:spPr>
         <p:txBody>
-          <a:bodyPr wrap="square" lIns="36576" rIns="36576" tIns="36576" bIns="36576" anchor="t">
+          <a:bodyPr wrap="square" lIns="36576" tIns="36576" rIns="36576" bIns="36576" anchor="t">
             <a:spAutoFit/>
           </a:bodyPr>
           <a:lstStyle/>
@@ -5329,6 +5435,7 @@
           <a:lstStyle/>
           <a:p>
             <a:pPr algn="ctr"/>
+            <a:endParaRPr/>
           </a:p>
         </p:txBody>
       </p:sp>
@@ -5349,7 +5456,7 @@
           <a:noFill/>
         </p:spPr>
         <p:txBody>
-          <a:bodyPr wrap="square" lIns="36576" rIns="36576" tIns="36576" bIns="36576" anchor="t">
+          <a:bodyPr wrap="square" lIns="36576" tIns="36576" rIns="36576" bIns="36576" anchor="t">
             <a:spAutoFit/>
           </a:bodyPr>
           <a:lstStyle/>
@@ -5380,7 +5487,7 @@
 </file>
 
 <file path=ppt/slides/slide11.xml><?xml version="1.0" encoding="utf-8"?>
-<p:sld xmlns:a="http://schemas.openxmlformats.org/drawingml/2006/main" xmlns:p="http://schemas.openxmlformats.org/presentationml/2006/main" xmlns:r="http://schemas.openxmlformats.org/officeDocument/2006/relationships">
+<p:sld xmlns:a="http://schemas.openxmlformats.org/drawingml/2006/main" xmlns:r="http://schemas.openxmlformats.org/officeDocument/2006/relationships" xmlns:p="http://schemas.openxmlformats.org/presentationml/2006/main">
   <p:cSld>
     <p:bg>
       <p:bgPr>
@@ -5396,7 +5503,14 @@
         <p:cNvGrpSpPr/>
         <p:nvPr/>
       </p:nvGrpSpPr>
-      <p:grpSpPr/>
+      <p:grpSpPr>
+        <a:xfrm>
+          <a:off x="0" y="0"/>
+          <a:ext cx="0" cy="0"/>
+          <a:chOff x="0" y="0"/>
+          <a:chExt cx="0" cy="0"/>
+        </a:xfrm>
+      </p:grpSpPr>
       <p:sp>
         <p:nvSpPr>
           <p:cNvPr id="2" name="Rectangle 1"/>
@@ -5439,6 +5553,7 @@
           <a:lstStyle/>
           <a:p>
             <a:pPr algn="ctr"/>
+            <a:endParaRPr/>
           </a:p>
         </p:txBody>
       </p:sp>
@@ -5459,7 +5574,7 @@
           <a:noFill/>
         </p:spPr>
         <p:txBody>
-          <a:bodyPr wrap="square" lIns="36576" rIns="36576" tIns="36576" bIns="36576" anchor="t">
+          <a:bodyPr wrap="square" lIns="36576" tIns="36576" rIns="36576" bIns="36576" anchor="t">
             <a:spAutoFit/>
           </a:bodyPr>
           <a:lstStyle/>
@@ -5498,7 +5613,7 @@
           <a:noFill/>
         </p:spPr>
         <p:txBody>
-          <a:bodyPr wrap="square" lIns="36576" rIns="36576" tIns="36576" bIns="36576" anchor="t">
+          <a:bodyPr wrap="square" lIns="36576" tIns="36576" rIns="36576" bIns="36576" anchor="t">
             <a:spAutoFit/>
           </a:bodyPr>
           <a:lstStyle/>
@@ -5562,6 +5677,7 @@
           <a:lstStyle/>
           <a:p>
             <a:pPr algn="ctr"/>
+            <a:endParaRPr/>
           </a:p>
         </p:txBody>
       </p:sp>
@@ -5582,7 +5698,7 @@
           <a:noFill/>
         </p:spPr>
         <p:txBody>
-          <a:bodyPr wrap="square" lIns="36576" rIns="36576" tIns="36576" bIns="36576" anchor="t">
+          <a:bodyPr wrap="square" lIns="36576" tIns="36576" rIns="36576" bIns="36576" anchor="t">
             <a:spAutoFit/>
           </a:bodyPr>
           <a:lstStyle/>
@@ -5621,7 +5737,7 @@
           <a:noFill/>
         </p:spPr>
         <p:txBody>
-          <a:bodyPr wrap="square" lIns="36576" rIns="36576" tIns="36576" bIns="36576" anchor="t">
+          <a:bodyPr wrap="square" lIns="36576" tIns="36576" rIns="36576" bIns="36576" anchor="t">
             <a:spAutoFit/>
           </a:bodyPr>
           <a:lstStyle/>
@@ -5695,7 +5811,7 @@
           <a:noFill/>
         </p:spPr>
         <p:txBody>
-          <a:bodyPr wrap="square" lIns="36576" rIns="36576" tIns="36576" bIns="36576" anchor="t">
+          <a:bodyPr wrap="square" lIns="36576" tIns="36576" rIns="36576" bIns="36576" anchor="t">
             <a:spAutoFit/>
           </a:bodyPr>
           <a:lstStyle/>
@@ -5769,7 +5885,7 @@
           <a:noFill/>
         </p:spPr>
         <p:txBody>
-          <a:bodyPr wrap="square" lIns="36576" rIns="36576" tIns="36576" bIns="36576" anchor="t">
+          <a:bodyPr wrap="square" lIns="36576" tIns="36576" rIns="36576" bIns="36576" anchor="t">
             <a:spAutoFit/>
           </a:bodyPr>
           <a:lstStyle/>
@@ -5843,7 +5959,7 @@
           <a:noFill/>
         </p:spPr>
         <p:txBody>
-          <a:bodyPr wrap="square" lIns="36576" rIns="36576" tIns="36576" bIns="36576" anchor="t">
+          <a:bodyPr wrap="square" lIns="36576" tIns="36576" rIns="36576" bIns="36576" anchor="t">
             <a:spAutoFit/>
           </a:bodyPr>
           <a:lstStyle/>
@@ -5917,7 +6033,7 @@
           <a:noFill/>
         </p:spPr>
         <p:txBody>
-          <a:bodyPr wrap="square" lIns="36576" rIns="36576" tIns="36576" bIns="36576" anchor="t">
+          <a:bodyPr wrap="square" lIns="36576" tIns="36576" rIns="36576" bIns="36576" anchor="t">
             <a:spAutoFit/>
           </a:bodyPr>
           <a:lstStyle/>
@@ -5991,7 +6107,7 @@
           <a:noFill/>
         </p:spPr>
         <p:txBody>
-          <a:bodyPr wrap="square" lIns="36576" rIns="36576" tIns="36576" bIns="36576" anchor="t">
+          <a:bodyPr wrap="square" lIns="36576" tIns="36576" rIns="36576" bIns="36576" anchor="t">
             <a:spAutoFit/>
           </a:bodyPr>
           <a:lstStyle/>
@@ -6065,7 +6181,7 @@
           <a:noFill/>
         </p:spPr>
         <p:txBody>
-          <a:bodyPr wrap="square" lIns="36576" rIns="36576" tIns="36576" bIns="36576" anchor="t">
+          <a:bodyPr wrap="square" lIns="36576" tIns="36576" rIns="36576" bIns="36576" anchor="t">
             <a:spAutoFit/>
           </a:bodyPr>
           <a:lstStyle/>
@@ -6104,7 +6220,7 @@
           <a:noFill/>
         </p:spPr>
         <p:txBody>
-          <a:bodyPr wrap="square" lIns="36576" rIns="36576" tIns="36576" bIns="36576" anchor="t">
+          <a:bodyPr wrap="square" lIns="36576" tIns="36576" rIns="36576" bIns="36576" anchor="t">
             <a:spAutoFit/>
           </a:bodyPr>
           <a:lstStyle/>
@@ -6170,6 +6286,7 @@
           <a:lstStyle/>
           <a:p>
             <a:pPr algn="ctr"/>
+            <a:endParaRPr/>
           </a:p>
         </p:txBody>
       </p:sp>
@@ -6190,7 +6307,7 @@
           <a:noFill/>
         </p:spPr>
         <p:txBody>
-          <a:bodyPr wrap="square" lIns="36576" rIns="36576" tIns="36576" bIns="36576" anchor="t">
+          <a:bodyPr wrap="square" lIns="36576" tIns="36576" rIns="36576" bIns="36576" anchor="t">
             <a:spAutoFit/>
           </a:bodyPr>
           <a:lstStyle/>
@@ -6229,7 +6346,7 @@
           <a:noFill/>
         </p:spPr>
         <p:txBody>
-          <a:bodyPr wrap="square" lIns="36576" rIns="36576" tIns="36576" bIns="36576" anchor="t">
+          <a:bodyPr wrap="square" lIns="36576" tIns="36576" rIns="36576" bIns="36576" anchor="t">
             <a:spAutoFit/>
           </a:bodyPr>
           <a:lstStyle/>
@@ -6295,6 +6412,7 @@
           <a:lstStyle/>
           <a:p>
             <a:pPr algn="ctr"/>
+            <a:endParaRPr/>
           </a:p>
         </p:txBody>
       </p:sp>
@@ -6315,7 +6433,7 @@
           <a:noFill/>
         </p:spPr>
         <p:txBody>
-          <a:bodyPr wrap="square" lIns="36576" rIns="36576" tIns="36576" bIns="36576" anchor="t">
+          <a:bodyPr wrap="square" lIns="36576" tIns="36576" rIns="36576" bIns="36576" anchor="t">
             <a:spAutoFit/>
           </a:bodyPr>
           <a:lstStyle/>
@@ -6354,7 +6472,7 @@
           <a:noFill/>
         </p:spPr>
         <p:txBody>
-          <a:bodyPr wrap="square" lIns="36576" rIns="36576" tIns="36576" bIns="36576" anchor="t">
+          <a:bodyPr wrap="square" lIns="36576" tIns="36576" rIns="36576" bIns="36576" anchor="t">
             <a:spAutoFit/>
           </a:bodyPr>
           <a:lstStyle/>
@@ -6395,13 +6513,55 @@
                 <a:tableStyleId>{5C22544A-7EE6-4342-B048-85BDC9FD1C3A}</a:tableStyleId>
               </a:tblPr>
               <a:tblGrid>
-                <a:gridCol w="1528354"/>
-                <a:gridCol w="1528354"/>
-                <a:gridCol w="1528354"/>
-                <a:gridCol w="1528354"/>
-                <a:gridCol w="1528354"/>
-                <a:gridCol w="1528354"/>
-                <a:gridCol w="1528354"/>
+                <a:gridCol w="1528354">
+                  <a:extLst>
+                    <a:ext uri="{9D8B030D-6E8A-4147-A177-3AD203B41FA5}">
+                      <a16:colId xmlns:a16="http://schemas.microsoft.com/office/drawing/2014/main" val="20000"/>
+                    </a:ext>
+                  </a:extLst>
+                </a:gridCol>
+                <a:gridCol w="1528354">
+                  <a:extLst>
+                    <a:ext uri="{9D8B030D-6E8A-4147-A177-3AD203B41FA5}">
+                      <a16:colId xmlns:a16="http://schemas.microsoft.com/office/drawing/2014/main" val="20001"/>
+                    </a:ext>
+                  </a:extLst>
+                </a:gridCol>
+                <a:gridCol w="1528354">
+                  <a:extLst>
+                    <a:ext uri="{9D8B030D-6E8A-4147-A177-3AD203B41FA5}">
+                      <a16:colId xmlns:a16="http://schemas.microsoft.com/office/drawing/2014/main" val="20002"/>
+                    </a:ext>
+                  </a:extLst>
+                </a:gridCol>
+                <a:gridCol w="1528354">
+                  <a:extLst>
+                    <a:ext uri="{9D8B030D-6E8A-4147-A177-3AD203B41FA5}">
+                      <a16:colId xmlns:a16="http://schemas.microsoft.com/office/drawing/2014/main" val="20003"/>
+                    </a:ext>
+                  </a:extLst>
+                </a:gridCol>
+                <a:gridCol w="1528354">
+                  <a:extLst>
+                    <a:ext uri="{9D8B030D-6E8A-4147-A177-3AD203B41FA5}">
+                      <a16:colId xmlns:a16="http://schemas.microsoft.com/office/drawing/2014/main" val="20004"/>
+                    </a:ext>
+                  </a:extLst>
+                </a:gridCol>
+                <a:gridCol w="1528354">
+                  <a:extLst>
+                    <a:ext uri="{9D8B030D-6E8A-4147-A177-3AD203B41FA5}">
+                      <a16:colId xmlns:a16="http://schemas.microsoft.com/office/drawing/2014/main" val="20005"/>
+                    </a:ext>
+                  </a:extLst>
+                </a:gridCol>
+                <a:gridCol w="1528354">
+                  <a:extLst>
+                    <a:ext uri="{9D8B030D-6E8A-4147-A177-3AD203B41FA5}">
+                      <a16:colId xmlns:a16="http://schemas.microsoft.com/office/drawing/2014/main" val="20006"/>
+                    </a:ext>
+                  </a:extLst>
+                </a:gridCol>
               </a:tblGrid>
               <a:tr h="365760">
                 <a:tc>
@@ -6572,6 +6732,11 @@
                     </a:solidFill>
                   </a:tcPr>
                 </a:tc>
+                <a:extLst>
+                  <a:ext uri="{0D108BD9-81ED-4DB2-BD59-A6C34878D82A}">
+                    <a16:rowId xmlns:a16="http://schemas.microsoft.com/office/drawing/2014/main" val="10000"/>
+                  </a:ext>
+                </a:extLst>
               </a:tr>
               <a:tr h="365760">
                 <a:tc>
@@ -6742,6 +6907,11 @@
                     </a:solidFill>
                   </a:tcPr>
                 </a:tc>
+                <a:extLst>
+                  <a:ext uri="{0D108BD9-81ED-4DB2-BD59-A6C34878D82A}">
+                    <a16:rowId xmlns:a16="http://schemas.microsoft.com/office/drawing/2014/main" val="10001"/>
+                  </a:ext>
+                </a:extLst>
               </a:tr>
               <a:tr h="365760">
                 <a:tc>
@@ -6912,6 +7082,11 @@
                     </a:solidFill>
                   </a:tcPr>
                 </a:tc>
+                <a:extLst>
+                  <a:ext uri="{0D108BD9-81ED-4DB2-BD59-A6C34878D82A}">
+                    <a16:rowId xmlns:a16="http://schemas.microsoft.com/office/drawing/2014/main" val="10002"/>
+                  </a:ext>
+                </a:extLst>
               </a:tr>
             </a:tbl>
           </a:graphicData>
@@ -6926,7 +7101,7 @@
 </file>
 
 <file path=ppt/slides/slide12.xml><?xml version="1.0" encoding="utf-8"?>
-<p:sld xmlns:a="http://schemas.openxmlformats.org/drawingml/2006/main" xmlns:p="http://schemas.openxmlformats.org/presentationml/2006/main" xmlns:r="http://schemas.openxmlformats.org/officeDocument/2006/relationships">
+<p:sld xmlns:a="http://schemas.openxmlformats.org/drawingml/2006/main" xmlns:r="http://schemas.openxmlformats.org/officeDocument/2006/relationships" xmlns:p="http://schemas.openxmlformats.org/presentationml/2006/main">
   <p:cSld>
     <p:bg>
       <p:bgPr>
@@ -6942,7 +7117,14 @@
         <p:cNvGrpSpPr/>
         <p:nvPr/>
       </p:nvGrpSpPr>
-      <p:grpSpPr/>
+      <p:grpSpPr>
+        <a:xfrm>
+          <a:off x="0" y="0"/>
+          <a:ext cx="0" cy="0"/>
+          <a:chOff x="0" y="0"/>
+          <a:chExt cx="0" cy="0"/>
+        </a:xfrm>
+      </p:grpSpPr>
       <p:sp>
         <p:nvSpPr>
           <p:cNvPr id="2" name="Rectangle 1"/>
@@ -6985,6 +7167,7 @@
           <a:lstStyle/>
           <a:p>
             <a:pPr algn="ctr"/>
+            <a:endParaRPr/>
           </a:p>
         </p:txBody>
       </p:sp>
@@ -7005,7 +7188,7 @@
           <a:noFill/>
         </p:spPr>
         <p:txBody>
-          <a:bodyPr wrap="square" lIns="36576" rIns="36576" tIns="36576" bIns="36576" anchor="t">
+          <a:bodyPr wrap="square" lIns="36576" tIns="36576" rIns="36576" bIns="36576" anchor="t">
             <a:spAutoFit/>
           </a:bodyPr>
           <a:lstStyle/>
@@ -7044,7 +7227,7 @@
           <a:noFill/>
         </p:spPr>
         <p:txBody>
-          <a:bodyPr wrap="square" lIns="36576" rIns="36576" tIns="36576" bIns="36576" anchor="t">
+          <a:bodyPr wrap="square" lIns="36576" tIns="36576" rIns="36576" bIns="36576" anchor="t">
             <a:spAutoFit/>
           </a:bodyPr>
           <a:lstStyle/>
@@ -7108,6 +7291,7 @@
           <a:lstStyle/>
           <a:p>
             <a:pPr algn="ctr"/>
+            <a:endParaRPr/>
           </a:p>
         </p:txBody>
       </p:sp>
@@ -7128,7 +7312,7 @@
           <a:noFill/>
         </p:spPr>
         <p:txBody>
-          <a:bodyPr wrap="square" lIns="36576" rIns="36576" tIns="36576" bIns="36576" anchor="t">
+          <a:bodyPr wrap="square" lIns="36576" tIns="36576" rIns="36576" bIns="36576" anchor="t">
             <a:spAutoFit/>
           </a:bodyPr>
           <a:lstStyle/>
@@ -7167,7 +7351,7 @@
           <a:noFill/>
         </p:spPr>
         <p:txBody>
-          <a:bodyPr wrap="square" lIns="36576" rIns="36576" tIns="36576" bIns="36576" anchor="t">
+          <a:bodyPr wrap="square" lIns="36576" tIns="36576" rIns="36576" bIns="36576" anchor="t">
             <a:spAutoFit/>
           </a:bodyPr>
           <a:lstStyle/>
@@ -7233,6 +7417,7 @@
           <a:lstStyle/>
           <a:p>
             <a:pPr algn="ctr"/>
+            <a:endParaRPr/>
           </a:p>
         </p:txBody>
       </p:sp>
@@ -7278,6 +7463,7 @@
           <a:lstStyle/>
           <a:p>
             <a:pPr algn="ctr"/>
+            <a:endParaRPr/>
           </a:p>
         </p:txBody>
       </p:sp>
@@ -7298,7 +7484,7 @@
           <a:noFill/>
         </p:spPr>
         <p:txBody>
-          <a:bodyPr wrap="square" lIns="36576" rIns="36576" tIns="36576" bIns="36576" anchor="t">
+          <a:bodyPr wrap="square" lIns="36576" tIns="36576" rIns="36576" bIns="36576" anchor="t">
             <a:spAutoFit/>
           </a:bodyPr>
           <a:lstStyle/>
@@ -7337,7 +7523,7 @@
           <a:noFill/>
         </p:spPr>
         <p:txBody>
-          <a:bodyPr wrap="square" lIns="36576" rIns="36576" tIns="36576" bIns="36576" anchor="t">
+          <a:bodyPr wrap="square" lIns="36576" tIns="36576" rIns="36576" bIns="36576" anchor="t">
             <a:spAutoFit/>
           </a:bodyPr>
           <a:lstStyle/>
@@ -7403,6 +7589,7 @@
           <a:lstStyle/>
           <a:p>
             <a:pPr algn="ctr"/>
+            <a:endParaRPr/>
           </a:p>
         </p:txBody>
       </p:sp>
@@ -7448,6 +7635,7 @@
           <a:lstStyle/>
           <a:p>
             <a:pPr algn="ctr"/>
+            <a:endParaRPr/>
           </a:p>
         </p:txBody>
       </p:sp>
@@ -7468,7 +7656,7 @@
           <a:noFill/>
         </p:spPr>
         <p:txBody>
-          <a:bodyPr wrap="square" lIns="36576" rIns="36576" tIns="36576" bIns="36576" anchor="t">
+          <a:bodyPr wrap="square" lIns="36576" tIns="36576" rIns="36576" bIns="36576" anchor="t">
             <a:spAutoFit/>
           </a:bodyPr>
           <a:lstStyle/>
@@ -7507,7 +7695,7 @@
           <a:noFill/>
         </p:spPr>
         <p:txBody>
-          <a:bodyPr wrap="square" lIns="36576" rIns="36576" tIns="36576" bIns="36576" anchor="t">
+          <a:bodyPr wrap="square" lIns="36576" tIns="36576" rIns="36576" bIns="36576" anchor="t">
             <a:spAutoFit/>
           </a:bodyPr>
           <a:lstStyle/>
@@ -7546,7 +7734,7 @@
           <a:noFill/>
         </p:spPr>
         <p:txBody>
-          <a:bodyPr wrap="square" lIns="36576" rIns="36576" tIns="36576" bIns="36576" anchor="t">
+          <a:bodyPr wrap="square" lIns="36576" tIns="36576" rIns="36576" bIns="36576" anchor="t">
             <a:spAutoFit/>
           </a:bodyPr>
           <a:lstStyle/>
@@ -7585,7 +7773,7 @@
           <a:noFill/>
         </p:spPr>
         <p:txBody>
-          <a:bodyPr wrap="square" lIns="36576" rIns="36576" tIns="36576" bIns="36576" anchor="t">
+          <a:bodyPr wrap="square" lIns="36576" tIns="36576" rIns="36576" bIns="36576" anchor="t">
             <a:spAutoFit/>
           </a:bodyPr>
           <a:lstStyle/>
@@ -7624,7 +7812,7 @@
           <a:noFill/>
         </p:spPr>
         <p:txBody>
-          <a:bodyPr wrap="square" lIns="36576" rIns="36576" tIns="36576" bIns="36576" anchor="t">
+          <a:bodyPr wrap="square" lIns="36576" tIns="36576" rIns="36576" bIns="36576" anchor="t">
             <a:spAutoFit/>
           </a:bodyPr>
           <a:lstStyle/>
@@ -7655,7 +7843,7 @@
 </file>
 
 <file path=ppt/slides/slide13.xml><?xml version="1.0" encoding="utf-8"?>
-<p:sld xmlns:a="http://schemas.openxmlformats.org/drawingml/2006/main" xmlns:p="http://schemas.openxmlformats.org/presentationml/2006/main" xmlns:r="http://schemas.openxmlformats.org/officeDocument/2006/relationships">
+<p:sld xmlns:a="http://schemas.openxmlformats.org/drawingml/2006/main" xmlns:r="http://schemas.openxmlformats.org/officeDocument/2006/relationships" xmlns:p="http://schemas.openxmlformats.org/presentationml/2006/main">
   <p:cSld>
     <p:bg>
       <p:bgPr>
@@ -7671,7 +7859,14 @@
         <p:cNvGrpSpPr/>
         <p:nvPr/>
       </p:nvGrpSpPr>
-      <p:grpSpPr/>
+      <p:grpSpPr>
+        <a:xfrm>
+          <a:off x="0" y="0"/>
+          <a:ext cx="0" cy="0"/>
+          <a:chOff x="0" y="0"/>
+          <a:chExt cx="0" cy="0"/>
+        </a:xfrm>
+      </p:grpSpPr>
       <p:sp>
         <p:nvSpPr>
           <p:cNvPr id="2" name="Rectangle 1"/>
@@ -7714,6 +7909,7 @@
           <a:lstStyle/>
           <a:p>
             <a:pPr algn="ctr"/>
+            <a:endParaRPr/>
           </a:p>
         </p:txBody>
       </p:sp>
@@ -7734,7 +7930,7 @@
           <a:noFill/>
         </p:spPr>
         <p:txBody>
-          <a:bodyPr wrap="square" lIns="36576" rIns="36576" tIns="36576" bIns="36576" anchor="t">
+          <a:bodyPr wrap="square" lIns="36576" tIns="36576" rIns="36576" bIns="36576" anchor="t">
             <a:spAutoFit/>
           </a:bodyPr>
           <a:lstStyle/>
@@ -7773,7 +7969,7 @@
           <a:noFill/>
         </p:spPr>
         <p:txBody>
-          <a:bodyPr wrap="square" lIns="36576" rIns="36576" tIns="36576" bIns="36576" anchor="t">
+          <a:bodyPr wrap="square" lIns="36576" tIns="36576" rIns="36576" bIns="36576" anchor="t">
             <a:spAutoFit/>
           </a:bodyPr>
           <a:lstStyle/>
@@ -7837,6 +8033,7 @@
           <a:lstStyle/>
           <a:p>
             <a:pPr algn="ctr"/>
+            <a:endParaRPr/>
           </a:p>
         </p:txBody>
       </p:sp>
@@ -7857,7 +8054,7 @@
           <a:noFill/>
         </p:spPr>
         <p:txBody>
-          <a:bodyPr wrap="square" lIns="36576" rIns="36576" tIns="36576" bIns="36576" anchor="t">
+          <a:bodyPr wrap="square" lIns="36576" tIns="36576" rIns="36576" bIns="36576" anchor="t">
             <a:spAutoFit/>
           </a:bodyPr>
           <a:lstStyle/>
@@ -7896,7 +8093,7 @@
           <a:noFill/>
         </p:spPr>
         <p:txBody>
-          <a:bodyPr wrap="square" lIns="36576" rIns="36576" tIns="36576" bIns="36576" anchor="t">
+          <a:bodyPr wrap="square" lIns="36576" tIns="36576" rIns="36576" bIns="36576" anchor="t">
             <a:spAutoFit/>
           </a:bodyPr>
           <a:lstStyle/>
@@ -7962,6 +8159,7 @@
           <a:lstStyle/>
           <a:p>
             <a:pPr algn="ctr"/>
+            <a:endParaRPr/>
           </a:p>
         </p:txBody>
       </p:sp>
@@ -7982,7 +8180,7 @@
           <a:noFill/>
         </p:spPr>
         <p:txBody>
-          <a:bodyPr wrap="square" lIns="36576" rIns="36576" tIns="36576" bIns="36576" anchor="t">
+          <a:bodyPr wrap="square" lIns="36576" tIns="36576" rIns="36576" bIns="36576" anchor="t">
             <a:spAutoFit/>
           </a:bodyPr>
           <a:lstStyle/>
@@ -8021,7 +8219,7 @@
           <a:noFill/>
         </p:spPr>
         <p:txBody>
-          <a:bodyPr wrap="square" lIns="36576" rIns="36576" tIns="36576" bIns="36576" anchor="t">
+          <a:bodyPr wrap="square" lIns="36576" tIns="36576" rIns="36576" bIns="36576" anchor="t">
             <a:spAutoFit/>
           </a:bodyPr>
           <a:lstStyle/>
@@ -8060,7 +8258,7 @@
           <a:noFill/>
         </p:spPr>
         <p:txBody>
-          <a:bodyPr wrap="square" lIns="36576" rIns="36576" tIns="36576" bIns="36576" anchor="t">
+          <a:bodyPr wrap="square" lIns="36576" tIns="36576" rIns="36576" bIns="36576" anchor="t">
             <a:spAutoFit/>
           </a:bodyPr>
           <a:lstStyle/>
@@ -8126,6 +8324,7 @@
           <a:lstStyle/>
           <a:p>
             <a:pPr algn="ctr"/>
+            <a:endParaRPr/>
           </a:p>
         </p:txBody>
       </p:sp>
@@ -8146,7 +8345,7 @@
           <a:noFill/>
         </p:spPr>
         <p:txBody>
-          <a:bodyPr wrap="square" lIns="36576" rIns="36576" tIns="36576" bIns="36576" anchor="t">
+          <a:bodyPr wrap="square" lIns="36576" tIns="36576" rIns="36576" bIns="36576" anchor="t">
             <a:spAutoFit/>
           </a:bodyPr>
           <a:lstStyle/>
@@ -8185,7 +8384,7 @@
           <a:noFill/>
         </p:spPr>
         <p:txBody>
-          <a:bodyPr wrap="square" lIns="36576" rIns="36576" tIns="36576" bIns="36576" anchor="t">
+          <a:bodyPr wrap="square" lIns="36576" tIns="36576" rIns="36576" bIns="36576" anchor="t">
             <a:spAutoFit/>
           </a:bodyPr>
           <a:lstStyle/>
@@ -8224,7 +8423,7 @@
           <a:noFill/>
         </p:spPr>
         <p:txBody>
-          <a:bodyPr wrap="square" lIns="36576" rIns="36576" tIns="36576" bIns="36576" anchor="t">
+          <a:bodyPr wrap="square" lIns="36576" tIns="36576" rIns="36576" bIns="36576" anchor="t">
             <a:spAutoFit/>
           </a:bodyPr>
           <a:lstStyle/>
@@ -8290,6 +8489,7 @@
           <a:lstStyle/>
           <a:p>
             <a:pPr algn="ctr"/>
+            <a:endParaRPr/>
           </a:p>
         </p:txBody>
       </p:sp>
@@ -8310,7 +8510,7 @@
           <a:noFill/>
         </p:spPr>
         <p:txBody>
-          <a:bodyPr wrap="square" lIns="36576" rIns="36576" tIns="36576" bIns="36576" anchor="t">
+          <a:bodyPr wrap="square" lIns="36576" tIns="36576" rIns="36576" bIns="36576" anchor="t">
             <a:spAutoFit/>
           </a:bodyPr>
           <a:lstStyle/>
@@ -8349,7 +8549,7 @@
           <a:noFill/>
         </p:spPr>
         <p:txBody>
-          <a:bodyPr wrap="square" lIns="36576" rIns="36576" tIns="36576" bIns="36576" anchor="t">
+          <a:bodyPr wrap="square" lIns="36576" tIns="36576" rIns="36576" bIns="36576" anchor="t">
             <a:spAutoFit/>
           </a:bodyPr>
           <a:lstStyle/>
@@ -8388,7 +8588,7 @@
           <a:noFill/>
         </p:spPr>
         <p:txBody>
-          <a:bodyPr wrap="square" lIns="36576" rIns="36576" tIns="36576" bIns="36576" anchor="t">
+          <a:bodyPr wrap="square" lIns="36576" tIns="36576" rIns="36576" bIns="36576" anchor="t">
             <a:spAutoFit/>
           </a:bodyPr>
           <a:lstStyle/>
@@ -8454,6 +8654,7 @@
           <a:lstStyle/>
           <a:p>
             <a:pPr algn="ctr"/>
+            <a:endParaRPr/>
           </a:p>
         </p:txBody>
       </p:sp>
@@ -8474,7 +8675,7 @@
           <a:noFill/>
         </p:spPr>
         <p:txBody>
-          <a:bodyPr wrap="square" lIns="36576" rIns="36576" tIns="36576" bIns="36576" anchor="t">
+          <a:bodyPr wrap="square" lIns="36576" tIns="36576" rIns="36576" bIns="36576" anchor="t">
             <a:spAutoFit/>
           </a:bodyPr>
           <a:lstStyle/>
@@ -8513,7 +8714,7 @@
           <a:noFill/>
         </p:spPr>
         <p:txBody>
-          <a:bodyPr wrap="square" lIns="36576" rIns="36576" tIns="36576" bIns="36576" anchor="t">
+          <a:bodyPr wrap="square" lIns="36576" tIns="36576" rIns="36576" bIns="36576" anchor="t">
             <a:spAutoFit/>
           </a:bodyPr>
           <a:lstStyle/>
@@ -8552,7 +8753,7 @@
           <a:noFill/>
         </p:spPr>
         <p:txBody>
-          <a:bodyPr wrap="square" lIns="36576" rIns="36576" tIns="36576" bIns="36576" anchor="t">
+          <a:bodyPr wrap="square" lIns="36576" tIns="36576" rIns="36576" bIns="36576" anchor="t">
             <a:spAutoFit/>
           </a:bodyPr>
           <a:lstStyle/>
@@ -8618,6 +8819,7 @@
           <a:lstStyle/>
           <a:p>
             <a:pPr algn="ctr"/>
+            <a:endParaRPr/>
           </a:p>
         </p:txBody>
       </p:sp>
@@ -8638,7 +8840,7 @@
           <a:noFill/>
         </p:spPr>
         <p:txBody>
-          <a:bodyPr wrap="square" lIns="36576" rIns="36576" tIns="36576" bIns="36576" anchor="t">
+          <a:bodyPr wrap="square" lIns="36576" tIns="36576" rIns="36576" bIns="36576" anchor="t">
             <a:spAutoFit/>
           </a:bodyPr>
           <a:lstStyle/>
@@ -8677,7 +8879,7 @@
           <a:noFill/>
         </p:spPr>
         <p:txBody>
-          <a:bodyPr wrap="square" lIns="36576" rIns="36576" tIns="36576" bIns="36576" anchor="t">
+          <a:bodyPr wrap="square" lIns="36576" tIns="36576" rIns="36576" bIns="36576" anchor="t">
             <a:spAutoFit/>
           </a:bodyPr>
           <a:lstStyle/>
@@ -8743,6 +8945,7 @@
           <a:lstStyle/>
           <a:p>
             <a:pPr algn="ctr"/>
+            <a:endParaRPr/>
           </a:p>
         </p:txBody>
       </p:sp>
@@ -8788,6 +8991,7 @@
           <a:lstStyle/>
           <a:p>
             <a:pPr algn="ctr"/>
+            <a:endParaRPr/>
           </a:p>
         </p:txBody>
       </p:sp>
@@ -8808,7 +9012,7 @@
           <a:noFill/>
         </p:spPr>
         <p:txBody>
-          <a:bodyPr wrap="square" lIns="36576" rIns="36576" tIns="36576" bIns="36576" anchor="t">
+          <a:bodyPr wrap="square" lIns="36576" tIns="36576" rIns="36576" bIns="36576" anchor="t">
             <a:spAutoFit/>
           </a:bodyPr>
           <a:lstStyle/>
@@ -8847,7 +9051,7 @@
           <a:noFill/>
         </p:spPr>
         <p:txBody>
-          <a:bodyPr wrap="square" lIns="36576" rIns="36576" tIns="36576" bIns="36576" anchor="t">
+          <a:bodyPr wrap="square" lIns="36576" tIns="36576" rIns="36576" bIns="36576" anchor="t">
             <a:spAutoFit/>
           </a:bodyPr>
           <a:lstStyle/>
@@ -8929,6 +9133,7 @@
           <a:lstStyle/>
           <a:p>
             <a:pPr algn="ctr"/>
+            <a:endParaRPr/>
           </a:p>
         </p:txBody>
       </p:sp>
@@ -8974,6 +9179,7 @@
           <a:lstStyle/>
           <a:p>
             <a:pPr algn="ctr"/>
+            <a:endParaRPr/>
           </a:p>
         </p:txBody>
       </p:sp>
@@ -8994,7 +9200,7 @@
           <a:noFill/>
         </p:spPr>
         <p:txBody>
-          <a:bodyPr wrap="square" lIns="36576" rIns="36576" tIns="36576" bIns="36576" anchor="t">
+          <a:bodyPr wrap="square" lIns="36576" tIns="36576" rIns="36576" bIns="36576" anchor="t">
             <a:spAutoFit/>
           </a:bodyPr>
           <a:lstStyle/>
@@ -9033,7 +9239,7 @@
           <a:noFill/>
         </p:spPr>
         <p:txBody>
-          <a:bodyPr wrap="square" lIns="36576" rIns="36576" tIns="36576" bIns="36576" anchor="t">
+          <a:bodyPr wrap="square" lIns="36576" tIns="36576" rIns="36576" bIns="36576" anchor="t">
             <a:spAutoFit/>
           </a:bodyPr>
           <a:lstStyle/>
@@ -9072,7 +9278,7 @@
           <a:noFill/>
         </p:spPr>
         <p:txBody>
-          <a:bodyPr wrap="square" lIns="36576" rIns="36576" tIns="36576" bIns="36576" anchor="t">
+          <a:bodyPr wrap="square" lIns="36576" tIns="36576" rIns="36576" bIns="36576" anchor="t">
             <a:spAutoFit/>
           </a:bodyPr>
           <a:lstStyle/>
@@ -9103,7 +9309,7 @@
 </file>
 
 <file path=ppt/slides/slide14.xml><?xml version="1.0" encoding="utf-8"?>
-<p:sld xmlns:a="http://schemas.openxmlformats.org/drawingml/2006/main" xmlns:p="http://schemas.openxmlformats.org/presentationml/2006/main" xmlns:r="http://schemas.openxmlformats.org/officeDocument/2006/relationships">
+<p:sld xmlns:a="http://schemas.openxmlformats.org/drawingml/2006/main" xmlns:r="http://schemas.openxmlformats.org/officeDocument/2006/relationships" xmlns:p="http://schemas.openxmlformats.org/presentationml/2006/main">
   <p:cSld>
     <p:bg>
       <p:bgPr>
@@ -9119,7 +9325,14 @@
         <p:cNvGrpSpPr/>
         <p:nvPr/>
       </p:nvGrpSpPr>
-      <p:grpSpPr/>
+      <p:grpSpPr>
+        <a:xfrm>
+          <a:off x="0" y="0"/>
+          <a:ext cx="0" cy="0"/>
+          <a:chOff x="0" y="0"/>
+          <a:chExt cx="0" cy="0"/>
+        </a:xfrm>
+      </p:grpSpPr>
       <p:sp>
         <p:nvSpPr>
           <p:cNvPr id="2" name="Rectangle 1"/>
@@ -9162,6 +9375,7 @@
           <a:lstStyle/>
           <a:p>
             <a:pPr algn="ctr"/>
+            <a:endParaRPr/>
           </a:p>
         </p:txBody>
       </p:sp>
@@ -9182,7 +9396,7 @@
           <a:noFill/>
         </p:spPr>
         <p:txBody>
-          <a:bodyPr wrap="square" lIns="36576" rIns="36576" tIns="36576" bIns="36576" anchor="t">
+          <a:bodyPr wrap="square" lIns="36576" tIns="36576" rIns="36576" bIns="36576" anchor="t">
             <a:spAutoFit/>
           </a:bodyPr>
           <a:lstStyle/>
@@ -9221,7 +9435,7 @@
           <a:noFill/>
         </p:spPr>
         <p:txBody>
-          <a:bodyPr wrap="square" lIns="36576" rIns="36576" tIns="36576" bIns="36576" anchor="t">
+          <a:bodyPr wrap="square" lIns="36576" tIns="36576" rIns="36576" bIns="36576" anchor="t">
             <a:spAutoFit/>
           </a:bodyPr>
           <a:lstStyle/>
@@ -9285,6 +9499,7 @@
           <a:lstStyle/>
           <a:p>
             <a:pPr algn="ctr"/>
+            <a:endParaRPr/>
           </a:p>
         </p:txBody>
       </p:sp>
@@ -9305,7 +9520,7 @@
           <a:noFill/>
         </p:spPr>
         <p:txBody>
-          <a:bodyPr wrap="square" lIns="36576" rIns="36576" tIns="36576" bIns="36576" anchor="t">
+          <a:bodyPr wrap="square" lIns="36576" tIns="36576" rIns="36576" bIns="36576" anchor="t">
             <a:spAutoFit/>
           </a:bodyPr>
           <a:lstStyle/>
@@ -9344,7 +9559,7 @@
           <a:noFill/>
         </p:spPr>
         <p:txBody>
-          <a:bodyPr wrap="square" lIns="36576" rIns="36576" tIns="36576" bIns="36576" anchor="t">
+          <a:bodyPr wrap="square" lIns="36576" tIns="36576" rIns="36576" bIns="36576" anchor="t">
             <a:spAutoFit/>
           </a:bodyPr>
           <a:lstStyle/>
@@ -9410,6 +9625,7 @@
           <a:lstStyle/>
           <a:p>
             <a:pPr algn="ctr"/>
+            <a:endParaRPr/>
           </a:p>
         </p:txBody>
       </p:sp>
@@ -9430,7 +9646,7 @@
           <a:noFill/>
         </p:spPr>
         <p:txBody>
-          <a:bodyPr wrap="square" lIns="36576" rIns="36576" tIns="36576" bIns="36576" anchor="t">
+          <a:bodyPr wrap="square" lIns="36576" tIns="36576" rIns="36576" bIns="36576" anchor="t">
             <a:spAutoFit/>
           </a:bodyPr>
           <a:lstStyle/>
@@ -9469,7 +9685,7 @@
           <a:noFill/>
         </p:spPr>
         <p:txBody>
-          <a:bodyPr wrap="square" lIns="36576" rIns="36576" tIns="36576" bIns="36576" anchor="t">
+          <a:bodyPr wrap="square" lIns="36576" tIns="36576" rIns="36576" bIns="36576" anchor="t">
             <a:spAutoFit/>
           </a:bodyPr>
           <a:lstStyle/>
@@ -9508,7 +9724,7 @@
           <a:noFill/>
         </p:spPr>
         <p:txBody>
-          <a:bodyPr wrap="square" lIns="36576" rIns="36576" tIns="36576" bIns="36576" anchor="t">
+          <a:bodyPr wrap="square" lIns="36576" tIns="36576" rIns="36576" bIns="36576" anchor="t">
             <a:spAutoFit/>
           </a:bodyPr>
           <a:lstStyle/>
@@ -9547,7 +9763,7 @@
           <a:noFill/>
         </p:spPr>
         <p:txBody>
-          <a:bodyPr wrap="square" lIns="36576" rIns="36576" tIns="36576" bIns="36576" anchor="t">
+          <a:bodyPr wrap="square" lIns="36576" tIns="36576" rIns="36576" bIns="36576" anchor="t">
             <a:spAutoFit/>
           </a:bodyPr>
           <a:lstStyle/>
@@ -9586,7 +9802,7 @@
           <a:noFill/>
         </p:spPr>
         <p:txBody>
-          <a:bodyPr wrap="square" lIns="36576" rIns="36576" tIns="36576" bIns="36576" anchor="t">
+          <a:bodyPr wrap="square" lIns="36576" tIns="36576" rIns="36576" bIns="36576" anchor="t">
             <a:spAutoFit/>
           </a:bodyPr>
           <a:lstStyle/>
@@ -9625,7 +9841,7 @@
           <a:noFill/>
         </p:spPr>
         <p:txBody>
-          <a:bodyPr wrap="square" lIns="36576" rIns="36576" tIns="36576" bIns="36576" anchor="t">
+          <a:bodyPr wrap="square" lIns="36576" tIns="36576" rIns="36576" bIns="36576" anchor="t">
             <a:spAutoFit/>
           </a:bodyPr>
           <a:lstStyle/>
@@ -9664,7 +9880,7 @@
           <a:noFill/>
         </p:spPr>
         <p:txBody>
-          <a:bodyPr wrap="square" lIns="36576" rIns="36576" tIns="36576" bIns="36576" anchor="t">
+          <a:bodyPr wrap="square" lIns="36576" tIns="36576" rIns="36576" bIns="36576" anchor="t">
             <a:spAutoFit/>
           </a:bodyPr>
           <a:lstStyle/>
@@ -9730,6 +9946,7 @@
           <a:lstStyle/>
           <a:p>
             <a:pPr algn="ctr"/>
+            <a:endParaRPr/>
           </a:p>
         </p:txBody>
       </p:sp>
@@ -9775,6 +9992,7 @@
           <a:lstStyle/>
           <a:p>
             <a:pPr algn="ctr"/>
+            <a:endParaRPr/>
           </a:p>
         </p:txBody>
       </p:sp>
@@ -9795,7 +10013,7 @@
           <a:noFill/>
         </p:spPr>
         <p:txBody>
-          <a:bodyPr wrap="square" lIns="36576" rIns="36576" tIns="36576" bIns="36576" anchor="t">
+          <a:bodyPr wrap="square" lIns="36576" tIns="36576" rIns="36576" bIns="36576" anchor="t">
             <a:spAutoFit/>
           </a:bodyPr>
           <a:lstStyle/>
@@ -9834,7 +10052,7 @@
           <a:noFill/>
         </p:spPr>
         <p:txBody>
-          <a:bodyPr wrap="square" lIns="36576" rIns="36576" tIns="36576" bIns="36576" anchor="t">
+          <a:bodyPr wrap="square" lIns="36576" tIns="36576" rIns="36576" bIns="36576" anchor="t">
             <a:spAutoFit/>
           </a:bodyPr>
           <a:lstStyle/>
@@ -9900,6 +10118,7 @@
           <a:lstStyle/>
           <a:p>
             <a:pPr algn="ctr"/>
+            <a:endParaRPr/>
           </a:p>
         </p:txBody>
       </p:sp>
@@ -9945,6 +10164,7 @@
           <a:lstStyle/>
           <a:p>
             <a:pPr algn="ctr"/>
+            <a:endParaRPr/>
           </a:p>
         </p:txBody>
       </p:sp>
@@ -9965,7 +10185,7 @@
           <a:noFill/>
         </p:spPr>
         <p:txBody>
-          <a:bodyPr wrap="square" lIns="36576" rIns="36576" tIns="36576" bIns="36576" anchor="t">
+          <a:bodyPr wrap="square" lIns="36576" tIns="36576" rIns="36576" bIns="36576" anchor="t">
             <a:spAutoFit/>
           </a:bodyPr>
           <a:lstStyle/>
@@ -10004,7 +10224,7 @@
           <a:noFill/>
         </p:spPr>
         <p:txBody>
-          <a:bodyPr wrap="square" lIns="36576" rIns="36576" tIns="36576" bIns="36576" anchor="t">
+          <a:bodyPr wrap="square" lIns="36576" tIns="36576" rIns="36576" bIns="36576" anchor="t">
             <a:spAutoFit/>
           </a:bodyPr>
           <a:lstStyle/>
@@ -10070,6 +10290,7 @@
           <a:lstStyle/>
           <a:p>
             <a:pPr algn="ctr"/>
+            <a:endParaRPr/>
           </a:p>
         </p:txBody>
       </p:sp>
@@ -10115,6 +10336,7 @@
           <a:lstStyle/>
           <a:p>
             <a:pPr algn="ctr"/>
+            <a:endParaRPr/>
           </a:p>
         </p:txBody>
       </p:sp>
@@ -10135,7 +10357,7 @@
           <a:noFill/>
         </p:spPr>
         <p:txBody>
-          <a:bodyPr wrap="square" lIns="36576" rIns="36576" tIns="36576" bIns="36576" anchor="t">
+          <a:bodyPr wrap="square" lIns="36576" tIns="36576" rIns="36576" bIns="36576" anchor="t">
             <a:spAutoFit/>
           </a:bodyPr>
           <a:lstStyle/>
@@ -10174,7 +10396,7 @@
           <a:noFill/>
         </p:spPr>
         <p:txBody>
-          <a:bodyPr wrap="square" lIns="36576" rIns="36576" tIns="36576" bIns="36576" anchor="t">
+          <a:bodyPr wrap="square" lIns="36576" tIns="36576" rIns="36576" bIns="36576" anchor="t">
             <a:spAutoFit/>
           </a:bodyPr>
           <a:lstStyle/>
@@ -10205,7 +10427,7 @@
 </file>
 
 <file path=ppt/slides/slide15.xml><?xml version="1.0" encoding="utf-8"?>
-<p:sld xmlns:a="http://schemas.openxmlformats.org/drawingml/2006/main" xmlns:p="http://schemas.openxmlformats.org/presentationml/2006/main" xmlns:r="http://schemas.openxmlformats.org/officeDocument/2006/relationships">
+<p:sld xmlns:a="http://schemas.openxmlformats.org/drawingml/2006/main" xmlns:r="http://schemas.openxmlformats.org/officeDocument/2006/relationships" xmlns:p="http://schemas.openxmlformats.org/presentationml/2006/main">
   <p:cSld>
     <p:bg>
       <p:bgPr>
@@ -10221,7 +10443,14 @@
         <p:cNvGrpSpPr/>
         <p:nvPr/>
       </p:nvGrpSpPr>
-      <p:grpSpPr/>
+      <p:grpSpPr>
+        <a:xfrm>
+          <a:off x="0" y="0"/>
+          <a:ext cx="0" cy="0"/>
+          <a:chOff x="0" y="0"/>
+          <a:chExt cx="0" cy="0"/>
+        </a:xfrm>
+      </p:grpSpPr>
       <p:sp>
         <p:nvSpPr>
           <p:cNvPr id="2" name="Rectangle 1"/>
@@ -10264,6 +10493,7 @@
           <a:lstStyle/>
           <a:p>
             <a:pPr algn="ctr"/>
+            <a:endParaRPr/>
           </a:p>
         </p:txBody>
       </p:sp>
@@ -10284,7 +10514,7 @@
           <a:noFill/>
         </p:spPr>
         <p:txBody>
-          <a:bodyPr wrap="square" lIns="36576" rIns="36576" tIns="36576" bIns="36576" anchor="t">
+          <a:bodyPr wrap="square" lIns="36576" tIns="36576" rIns="36576" bIns="36576" anchor="t">
             <a:spAutoFit/>
           </a:bodyPr>
           <a:lstStyle/>
@@ -10323,7 +10553,7 @@
           <a:noFill/>
         </p:spPr>
         <p:txBody>
-          <a:bodyPr wrap="square" lIns="36576" rIns="36576" tIns="36576" bIns="36576" anchor="t">
+          <a:bodyPr wrap="square" lIns="36576" tIns="36576" rIns="36576" bIns="36576" anchor="t">
             <a:spAutoFit/>
           </a:bodyPr>
           <a:lstStyle/>
@@ -10387,6 +10617,7 @@
           <a:lstStyle/>
           <a:p>
             <a:pPr algn="ctr"/>
+            <a:endParaRPr/>
           </a:p>
         </p:txBody>
       </p:sp>
@@ -10407,7 +10638,7 @@
           <a:noFill/>
         </p:spPr>
         <p:txBody>
-          <a:bodyPr wrap="square" lIns="36576" rIns="36576" tIns="36576" bIns="36576" anchor="t">
+          <a:bodyPr wrap="square" lIns="36576" tIns="36576" rIns="36576" bIns="36576" anchor="t">
             <a:spAutoFit/>
           </a:bodyPr>
           <a:lstStyle/>
@@ -10446,7 +10677,7 @@
           <a:noFill/>
         </p:spPr>
         <p:txBody>
-          <a:bodyPr wrap="square" lIns="36576" rIns="36576" tIns="36576" bIns="36576" anchor="t">
+          <a:bodyPr wrap="square" lIns="36576" tIns="36576" rIns="36576" bIns="36576" anchor="t">
             <a:spAutoFit/>
           </a:bodyPr>
           <a:lstStyle/>
@@ -10512,6 +10743,7 @@
           <a:lstStyle/>
           <a:p>
             <a:pPr algn="ctr"/>
+            <a:endParaRPr/>
           </a:p>
         </p:txBody>
       </p:sp>
@@ -10557,6 +10789,7 @@
           <a:lstStyle/>
           <a:p>
             <a:pPr algn="ctr"/>
+            <a:endParaRPr/>
           </a:p>
         </p:txBody>
       </p:sp>
@@ -10577,7 +10810,7 @@
           <a:noFill/>
         </p:spPr>
         <p:txBody>
-          <a:bodyPr wrap="square" lIns="36576" rIns="36576" tIns="36576" bIns="36576" anchor="t">
+          <a:bodyPr wrap="square" lIns="36576" tIns="36576" rIns="36576" bIns="36576" anchor="t">
             <a:spAutoFit/>
           </a:bodyPr>
           <a:lstStyle/>
@@ -10616,7 +10849,7 @@
           <a:noFill/>
         </p:spPr>
         <p:txBody>
-          <a:bodyPr wrap="square" lIns="36576" rIns="36576" tIns="36576" bIns="36576" anchor="t">
+          <a:bodyPr wrap="square" lIns="36576" tIns="36576" rIns="36576" bIns="36576" anchor="t">
             <a:spAutoFit/>
           </a:bodyPr>
           <a:lstStyle/>
@@ -10682,6 +10915,7 @@
           <a:lstStyle/>
           <a:p>
             <a:pPr algn="ctr"/>
+            <a:endParaRPr/>
           </a:p>
         </p:txBody>
       </p:sp>
@@ -10727,6 +10961,7 @@
           <a:lstStyle/>
           <a:p>
             <a:pPr algn="ctr"/>
+            <a:endParaRPr/>
           </a:p>
         </p:txBody>
       </p:sp>
@@ -10747,7 +10982,7 @@
           <a:noFill/>
         </p:spPr>
         <p:txBody>
-          <a:bodyPr wrap="square" lIns="36576" rIns="36576" tIns="36576" bIns="36576" anchor="t">
+          <a:bodyPr wrap="square" lIns="36576" tIns="36576" rIns="36576" bIns="36576" anchor="t">
             <a:spAutoFit/>
           </a:bodyPr>
           <a:lstStyle/>
@@ -10786,7 +11021,7 @@
           <a:noFill/>
         </p:spPr>
         <p:txBody>
-          <a:bodyPr wrap="square" lIns="36576" rIns="36576" tIns="36576" bIns="36576" anchor="t">
+          <a:bodyPr wrap="square" lIns="36576" tIns="36576" rIns="36576" bIns="36576" anchor="t">
             <a:spAutoFit/>
           </a:bodyPr>
           <a:lstStyle/>
@@ -10852,6 +11087,7 @@
           <a:lstStyle/>
           <a:p>
             <a:pPr algn="ctr"/>
+            <a:endParaRPr/>
           </a:p>
         </p:txBody>
       </p:sp>
@@ -10897,6 +11133,7 @@
           <a:lstStyle/>
           <a:p>
             <a:pPr algn="ctr"/>
+            <a:endParaRPr/>
           </a:p>
         </p:txBody>
       </p:sp>
@@ -10917,7 +11154,7 @@
           <a:noFill/>
         </p:spPr>
         <p:txBody>
-          <a:bodyPr wrap="square" lIns="36576" rIns="36576" tIns="36576" bIns="36576" anchor="t">
+          <a:bodyPr wrap="square" lIns="36576" tIns="36576" rIns="36576" bIns="36576" anchor="t">
             <a:spAutoFit/>
           </a:bodyPr>
           <a:lstStyle/>
@@ -10956,7 +11193,7 @@
           <a:noFill/>
         </p:spPr>
         <p:txBody>
-          <a:bodyPr wrap="square" lIns="36576" rIns="36576" tIns="36576" bIns="36576" anchor="t">
+          <a:bodyPr wrap="square" lIns="36576" tIns="36576" rIns="36576" bIns="36576" anchor="t">
             <a:spAutoFit/>
           </a:bodyPr>
           <a:lstStyle/>
@@ -10995,7 +11232,7 @@
           <a:noFill/>
         </p:spPr>
         <p:txBody>
-          <a:bodyPr wrap="square" lIns="36576" rIns="36576" tIns="36576" bIns="36576" anchor="t">
+          <a:bodyPr wrap="square" lIns="36576" tIns="36576" rIns="36576" bIns="36576" anchor="t">
             <a:spAutoFit/>
           </a:bodyPr>
           <a:lstStyle/>
@@ -11034,7 +11271,7 @@
           <a:noFill/>
         </p:spPr>
         <p:txBody>
-          <a:bodyPr wrap="square" lIns="36576" rIns="36576" tIns="36576" bIns="36576" anchor="t">
+          <a:bodyPr wrap="square" lIns="36576" tIns="36576" rIns="36576" bIns="36576" anchor="t">
             <a:spAutoFit/>
           </a:bodyPr>
           <a:lstStyle/>
@@ -11073,7 +11310,7 @@
           <a:noFill/>
         </p:spPr>
         <p:txBody>
-          <a:bodyPr wrap="square" lIns="36576" rIns="36576" tIns="36576" bIns="36576" anchor="t">
+          <a:bodyPr wrap="square" lIns="36576" tIns="36576" rIns="36576" bIns="36576" anchor="t">
             <a:spAutoFit/>
           </a:bodyPr>
           <a:lstStyle/>
@@ -11104,7 +11341,7 @@
 </file>
 
 <file path=ppt/slides/slide2.xml><?xml version="1.0" encoding="utf-8"?>
-<p:sld xmlns:a="http://schemas.openxmlformats.org/drawingml/2006/main" xmlns:p="http://schemas.openxmlformats.org/presentationml/2006/main" xmlns:r="http://schemas.openxmlformats.org/officeDocument/2006/relationships">
+<p:sld xmlns:a="http://schemas.openxmlformats.org/drawingml/2006/main" xmlns:r="http://schemas.openxmlformats.org/officeDocument/2006/relationships" xmlns:p="http://schemas.openxmlformats.org/presentationml/2006/main">
   <p:cSld>
     <p:bg>
       <p:bgPr>
@@ -11120,7 +11357,14 @@
         <p:cNvGrpSpPr/>
         <p:nvPr/>
       </p:nvGrpSpPr>
-      <p:grpSpPr/>
+      <p:grpSpPr>
+        <a:xfrm>
+          <a:off x="0" y="0"/>
+          <a:ext cx="0" cy="0"/>
+          <a:chOff x="0" y="0"/>
+          <a:chExt cx="0" cy="0"/>
+        </a:xfrm>
+      </p:grpSpPr>
       <p:sp>
         <p:nvSpPr>
           <p:cNvPr id="2" name="Rectangle 1"/>
@@ -11163,6 +11407,7 @@
           <a:lstStyle/>
           <a:p>
             <a:pPr algn="ctr"/>
+            <a:endParaRPr/>
           </a:p>
         </p:txBody>
       </p:sp>
@@ -11183,7 +11428,7 @@
           <a:noFill/>
         </p:spPr>
         <p:txBody>
-          <a:bodyPr wrap="square" lIns="36576" rIns="36576" tIns="36576" bIns="36576" anchor="t">
+          <a:bodyPr wrap="square" lIns="36576" tIns="36576" rIns="36576" bIns="36576" anchor="t">
             <a:spAutoFit/>
           </a:bodyPr>
           <a:lstStyle/>
@@ -11222,7 +11467,7 @@
           <a:noFill/>
         </p:spPr>
         <p:txBody>
-          <a:bodyPr wrap="square" lIns="36576" rIns="36576" tIns="36576" bIns="36576" anchor="t">
+          <a:bodyPr wrap="square" lIns="36576" tIns="36576" rIns="36576" bIns="36576" anchor="t">
             <a:spAutoFit/>
           </a:bodyPr>
           <a:lstStyle/>
@@ -11286,6 +11531,7 @@
           <a:lstStyle/>
           <a:p>
             <a:pPr algn="ctr"/>
+            <a:endParaRPr/>
           </a:p>
         </p:txBody>
       </p:sp>
@@ -11306,7 +11552,7 @@
           <a:noFill/>
         </p:spPr>
         <p:txBody>
-          <a:bodyPr wrap="square" lIns="36576" rIns="36576" tIns="36576" bIns="36576" anchor="t">
+          <a:bodyPr wrap="square" lIns="36576" tIns="36576" rIns="36576" bIns="36576" anchor="t">
             <a:spAutoFit/>
           </a:bodyPr>
           <a:lstStyle/>
@@ -11345,7 +11591,7 @@
           <a:noFill/>
         </p:spPr>
         <p:txBody>
-          <a:bodyPr wrap="square" lIns="36576" rIns="36576" tIns="36576" bIns="36576" anchor="t">
+          <a:bodyPr wrap="square" lIns="36576" tIns="36576" rIns="36576" bIns="36576" anchor="t">
             <a:spAutoFit/>
           </a:bodyPr>
           <a:lstStyle/>
@@ -11411,6 +11657,7 @@
           <a:lstStyle/>
           <a:p>
             <a:pPr algn="ctr"/>
+            <a:endParaRPr/>
           </a:p>
         </p:txBody>
       </p:sp>
@@ -11431,7 +11678,7 @@
           <a:noFill/>
         </p:spPr>
         <p:txBody>
-          <a:bodyPr wrap="square" lIns="36576" rIns="36576" tIns="36576" bIns="36576" anchor="t">
+          <a:bodyPr wrap="square" lIns="36576" tIns="36576" rIns="36576" bIns="36576" anchor="t">
             <a:spAutoFit/>
           </a:bodyPr>
           <a:lstStyle/>
@@ -11470,7 +11717,7 @@
           <a:noFill/>
         </p:spPr>
         <p:txBody>
-          <a:bodyPr wrap="square" lIns="36576" rIns="36576" tIns="36576" bIns="36576" anchor="t">
+          <a:bodyPr wrap="square" lIns="36576" tIns="36576" rIns="36576" bIns="36576" anchor="t">
             <a:spAutoFit/>
           </a:bodyPr>
           <a:lstStyle/>
@@ -11509,7 +11756,7 @@
           <a:noFill/>
         </p:spPr>
         <p:txBody>
-          <a:bodyPr wrap="square" lIns="36576" rIns="36576" tIns="36576" bIns="36576" anchor="t">
+          <a:bodyPr wrap="square" lIns="36576" tIns="36576" rIns="36576" bIns="36576" anchor="t">
             <a:spAutoFit/>
           </a:bodyPr>
           <a:lstStyle/>
@@ -11575,6 +11822,7 @@
           <a:lstStyle/>
           <a:p>
             <a:pPr algn="ctr"/>
+            <a:endParaRPr/>
           </a:p>
         </p:txBody>
       </p:sp>
@@ -11595,7 +11843,7 @@
           <a:noFill/>
         </p:spPr>
         <p:txBody>
-          <a:bodyPr wrap="square" lIns="36576" rIns="36576" tIns="36576" bIns="36576" anchor="t">
+          <a:bodyPr wrap="square" lIns="36576" tIns="36576" rIns="36576" bIns="36576" anchor="t">
             <a:spAutoFit/>
           </a:bodyPr>
           <a:lstStyle/>
@@ -11634,7 +11882,7 @@
           <a:noFill/>
         </p:spPr>
         <p:txBody>
-          <a:bodyPr wrap="square" lIns="36576" rIns="36576" tIns="36576" bIns="36576" anchor="t">
+          <a:bodyPr wrap="square" lIns="36576" tIns="36576" rIns="36576" bIns="36576" anchor="t">
             <a:spAutoFit/>
           </a:bodyPr>
           <a:lstStyle/>
@@ -11673,7 +11921,7 @@
           <a:noFill/>
         </p:spPr>
         <p:txBody>
-          <a:bodyPr wrap="square" lIns="36576" rIns="36576" tIns="36576" bIns="36576" anchor="t">
+          <a:bodyPr wrap="square" lIns="36576" tIns="36576" rIns="36576" bIns="36576" anchor="t">
             <a:spAutoFit/>
           </a:bodyPr>
           <a:lstStyle/>
@@ -11739,6 +11987,7 @@
           <a:lstStyle/>
           <a:p>
             <a:pPr algn="ctr"/>
+            <a:endParaRPr/>
           </a:p>
         </p:txBody>
       </p:sp>
@@ -11759,7 +12008,7 @@
           <a:noFill/>
         </p:spPr>
         <p:txBody>
-          <a:bodyPr wrap="square" lIns="36576" rIns="36576" tIns="36576" bIns="36576" anchor="t">
+          <a:bodyPr wrap="square" lIns="36576" tIns="36576" rIns="36576" bIns="36576" anchor="t">
             <a:spAutoFit/>
           </a:bodyPr>
           <a:lstStyle/>
@@ -11798,7 +12047,7 @@
           <a:noFill/>
         </p:spPr>
         <p:txBody>
-          <a:bodyPr wrap="square" lIns="36576" rIns="36576" tIns="36576" bIns="36576" anchor="t">
+          <a:bodyPr wrap="square" lIns="36576" tIns="36576" rIns="36576" bIns="36576" anchor="t">
             <a:spAutoFit/>
           </a:bodyPr>
           <a:lstStyle/>
@@ -11837,7 +12086,7 @@
           <a:noFill/>
         </p:spPr>
         <p:txBody>
-          <a:bodyPr wrap="square" lIns="36576" rIns="36576" tIns="36576" bIns="36576" anchor="t">
+          <a:bodyPr wrap="square" lIns="36576" tIns="36576" rIns="36576" bIns="36576" anchor="t">
             <a:spAutoFit/>
           </a:bodyPr>
           <a:lstStyle/>
@@ -11903,6 +12152,7 @@
           <a:lstStyle/>
           <a:p>
             <a:pPr algn="ctr"/>
+            <a:endParaRPr/>
           </a:p>
         </p:txBody>
       </p:sp>
@@ -11923,7 +12173,7 @@
           <a:noFill/>
         </p:spPr>
         <p:txBody>
-          <a:bodyPr wrap="square" lIns="36576" rIns="36576" tIns="36576" bIns="36576" anchor="t">
+          <a:bodyPr wrap="square" lIns="36576" tIns="36576" rIns="36576" bIns="36576" anchor="t">
             <a:spAutoFit/>
           </a:bodyPr>
           <a:lstStyle/>
@@ -11962,7 +12212,7 @@
           <a:noFill/>
         </p:spPr>
         <p:txBody>
-          <a:bodyPr wrap="square" lIns="36576" rIns="36576" tIns="36576" bIns="36576" anchor="t">
+          <a:bodyPr wrap="square" lIns="36576" tIns="36576" rIns="36576" bIns="36576" anchor="t">
             <a:spAutoFit/>
           </a:bodyPr>
           <a:lstStyle/>
@@ -12001,7 +12251,7 @@
           <a:noFill/>
         </p:spPr>
         <p:txBody>
-          <a:bodyPr wrap="square" lIns="36576" rIns="36576" tIns="36576" bIns="36576" anchor="t">
+          <a:bodyPr wrap="square" lIns="36576" tIns="36576" rIns="36576" bIns="36576" anchor="t">
             <a:spAutoFit/>
           </a:bodyPr>
           <a:lstStyle/>
@@ -12067,6 +12317,7 @@
           <a:lstStyle/>
           <a:p>
             <a:pPr algn="ctr"/>
+            <a:endParaRPr/>
           </a:p>
         </p:txBody>
       </p:sp>
@@ -12087,7 +12338,7 @@
           <a:noFill/>
         </p:spPr>
         <p:txBody>
-          <a:bodyPr wrap="square" lIns="36576" rIns="36576" tIns="36576" bIns="36576" anchor="t">
+          <a:bodyPr wrap="square" lIns="36576" tIns="36576" rIns="36576" bIns="36576" anchor="t">
             <a:spAutoFit/>
           </a:bodyPr>
           <a:lstStyle/>
@@ -12126,7 +12377,7 @@
           <a:noFill/>
         </p:spPr>
         <p:txBody>
-          <a:bodyPr wrap="square" lIns="36576" rIns="36576" tIns="36576" bIns="36576" anchor="t">
+          <a:bodyPr wrap="square" lIns="36576" tIns="36576" rIns="36576" bIns="36576" anchor="t">
             <a:spAutoFit/>
           </a:bodyPr>
           <a:lstStyle/>
@@ -12192,6 +12443,7 @@
           <a:lstStyle/>
           <a:p>
             <a:pPr algn="ctr"/>
+            <a:endParaRPr/>
           </a:p>
         </p:txBody>
       </p:sp>
@@ -12237,6 +12489,7 @@
           <a:lstStyle/>
           <a:p>
             <a:pPr algn="ctr"/>
+            <a:endParaRPr/>
           </a:p>
         </p:txBody>
       </p:sp>
@@ -12257,7 +12510,7 @@
           <a:noFill/>
         </p:spPr>
         <p:txBody>
-          <a:bodyPr wrap="square" lIns="36576" rIns="36576" tIns="36576" bIns="36576" anchor="t">
+          <a:bodyPr wrap="square" lIns="36576" tIns="36576" rIns="36576" bIns="36576" anchor="t">
             <a:spAutoFit/>
           </a:bodyPr>
           <a:lstStyle/>
@@ -12296,7 +12549,7 @@
           <a:noFill/>
         </p:spPr>
         <p:txBody>
-          <a:bodyPr wrap="square" lIns="36576" rIns="36576" tIns="36576" bIns="36576" anchor="t">
+          <a:bodyPr wrap="square" lIns="36576" tIns="36576" rIns="36576" bIns="36576" anchor="t">
             <a:spAutoFit/>
           </a:bodyPr>
           <a:lstStyle/>
@@ -12362,6 +12615,7 @@
           <a:lstStyle/>
           <a:p>
             <a:pPr algn="ctr"/>
+            <a:endParaRPr/>
           </a:p>
         </p:txBody>
       </p:sp>
@@ -12407,6 +12661,7 @@
           <a:lstStyle/>
           <a:p>
             <a:pPr algn="ctr"/>
+            <a:endParaRPr/>
           </a:p>
         </p:txBody>
       </p:sp>
@@ -12427,7 +12682,7 @@
           <a:noFill/>
         </p:spPr>
         <p:txBody>
-          <a:bodyPr wrap="square" lIns="36576" rIns="36576" tIns="36576" bIns="36576" anchor="t">
+          <a:bodyPr wrap="square" lIns="36576" tIns="36576" rIns="36576" bIns="36576" anchor="t">
             <a:spAutoFit/>
           </a:bodyPr>
           <a:lstStyle/>
@@ -12466,7 +12721,7 @@
           <a:noFill/>
         </p:spPr>
         <p:txBody>
-          <a:bodyPr wrap="square" lIns="36576" rIns="36576" tIns="36576" bIns="36576" anchor="t">
+          <a:bodyPr wrap="square" lIns="36576" tIns="36576" rIns="36576" bIns="36576" anchor="t">
             <a:spAutoFit/>
           </a:bodyPr>
           <a:lstStyle/>
@@ -12532,6 +12787,7 @@
           <a:lstStyle/>
           <a:p>
             <a:pPr algn="ctr"/>
+            <a:endParaRPr/>
           </a:p>
         </p:txBody>
       </p:sp>
@@ -12577,6 +12833,7 @@
           <a:lstStyle/>
           <a:p>
             <a:pPr algn="ctr"/>
+            <a:endParaRPr/>
           </a:p>
         </p:txBody>
       </p:sp>
@@ -12597,7 +12854,7 @@
           <a:noFill/>
         </p:spPr>
         <p:txBody>
-          <a:bodyPr wrap="square" lIns="36576" rIns="36576" tIns="36576" bIns="36576" anchor="t">
+          <a:bodyPr wrap="square" lIns="36576" tIns="36576" rIns="36576" bIns="36576" anchor="t">
             <a:spAutoFit/>
           </a:bodyPr>
           <a:lstStyle/>
@@ -12636,7 +12893,7 @@
           <a:noFill/>
         </p:spPr>
         <p:txBody>
-          <a:bodyPr wrap="square" lIns="36576" rIns="36576" tIns="36576" bIns="36576" anchor="t">
+          <a:bodyPr wrap="square" lIns="36576" tIns="36576" rIns="36576" bIns="36576" anchor="t">
             <a:spAutoFit/>
           </a:bodyPr>
           <a:lstStyle/>
@@ -12702,6 +12959,7 @@
           <a:lstStyle/>
           <a:p>
             <a:pPr algn="ctr"/>
+            <a:endParaRPr/>
           </a:p>
         </p:txBody>
       </p:sp>
@@ -12747,6 +13005,7 @@
           <a:lstStyle/>
           <a:p>
             <a:pPr algn="ctr"/>
+            <a:endParaRPr/>
           </a:p>
         </p:txBody>
       </p:sp>
@@ -12767,7 +13026,7 @@
           <a:noFill/>
         </p:spPr>
         <p:txBody>
-          <a:bodyPr wrap="square" lIns="36576" rIns="36576" tIns="36576" bIns="36576" anchor="t">
+          <a:bodyPr wrap="square" lIns="36576" tIns="36576" rIns="36576" bIns="36576" anchor="t">
             <a:spAutoFit/>
           </a:bodyPr>
           <a:lstStyle/>
@@ -12806,7 +13065,7 @@
           <a:noFill/>
         </p:spPr>
         <p:txBody>
-          <a:bodyPr wrap="square" lIns="36576" rIns="36576" tIns="36576" bIns="36576" anchor="t">
+          <a:bodyPr wrap="square" lIns="36576" tIns="36576" rIns="36576" bIns="36576" anchor="t">
             <a:spAutoFit/>
           </a:bodyPr>
           <a:lstStyle/>
@@ -12845,7 +13104,7 @@
           <a:noFill/>
         </p:spPr>
         <p:txBody>
-          <a:bodyPr wrap="square" lIns="36576" rIns="36576" tIns="36576" bIns="36576" anchor="t">
+          <a:bodyPr wrap="square" lIns="36576" tIns="36576" rIns="36576" bIns="36576" anchor="t">
             <a:spAutoFit/>
           </a:bodyPr>
           <a:lstStyle/>
@@ -12876,7 +13135,7 @@
 </file>
 
 <file path=ppt/slides/slide3.xml><?xml version="1.0" encoding="utf-8"?>
-<p:sld xmlns:a="http://schemas.openxmlformats.org/drawingml/2006/main" xmlns:p="http://schemas.openxmlformats.org/presentationml/2006/main" xmlns:r="http://schemas.openxmlformats.org/officeDocument/2006/relationships">
+<p:sld xmlns:a="http://schemas.openxmlformats.org/drawingml/2006/main" xmlns:r="http://schemas.openxmlformats.org/officeDocument/2006/relationships" xmlns:p="http://schemas.openxmlformats.org/presentationml/2006/main">
   <p:cSld>
     <p:bg>
       <p:bgPr>
@@ -12892,7 +13151,14 @@
         <p:cNvGrpSpPr/>
         <p:nvPr/>
       </p:nvGrpSpPr>
-      <p:grpSpPr/>
+      <p:grpSpPr>
+        <a:xfrm>
+          <a:off x="0" y="0"/>
+          <a:ext cx="0" cy="0"/>
+          <a:chOff x="0" y="0"/>
+          <a:chExt cx="0" cy="0"/>
+        </a:xfrm>
+      </p:grpSpPr>
       <p:sp>
         <p:nvSpPr>
           <p:cNvPr id="2" name="Rectangle 1"/>
@@ -12935,6 +13201,7 @@
           <a:lstStyle/>
           <a:p>
             <a:pPr algn="ctr"/>
+            <a:endParaRPr/>
           </a:p>
         </p:txBody>
       </p:sp>
@@ -12955,7 +13222,7 @@
           <a:noFill/>
         </p:spPr>
         <p:txBody>
-          <a:bodyPr wrap="square" lIns="36576" rIns="36576" tIns="36576" bIns="36576" anchor="t">
+          <a:bodyPr wrap="square" lIns="36576" tIns="36576" rIns="36576" bIns="36576" anchor="t">
             <a:spAutoFit/>
           </a:bodyPr>
           <a:lstStyle/>
@@ -12994,7 +13261,7 @@
           <a:noFill/>
         </p:spPr>
         <p:txBody>
-          <a:bodyPr wrap="square" lIns="36576" rIns="36576" tIns="36576" bIns="36576" anchor="t">
+          <a:bodyPr wrap="square" lIns="36576" tIns="36576" rIns="36576" bIns="36576" anchor="t">
             <a:spAutoFit/>
           </a:bodyPr>
           <a:lstStyle/>
@@ -13058,6 +13325,7 @@
           <a:lstStyle/>
           <a:p>
             <a:pPr algn="ctr"/>
+            <a:endParaRPr/>
           </a:p>
         </p:txBody>
       </p:sp>
@@ -13078,7 +13346,7 @@
           <a:noFill/>
         </p:spPr>
         <p:txBody>
-          <a:bodyPr wrap="square" lIns="36576" rIns="36576" tIns="36576" bIns="36576" anchor="t">
+          <a:bodyPr wrap="square" lIns="36576" tIns="36576" rIns="36576" bIns="36576" anchor="t">
             <a:spAutoFit/>
           </a:bodyPr>
           <a:lstStyle/>
@@ -13117,7 +13385,7 @@
           <a:noFill/>
         </p:spPr>
         <p:txBody>
-          <a:bodyPr wrap="square" lIns="36576" rIns="36576" tIns="36576" bIns="36576" anchor="t">
+          <a:bodyPr wrap="square" lIns="36576" tIns="36576" rIns="36576" bIns="36576" anchor="t">
             <a:spAutoFit/>
           </a:bodyPr>
           <a:lstStyle/>
@@ -13183,6 +13451,7 @@
           <a:lstStyle/>
           <a:p>
             <a:pPr algn="ctr"/>
+            <a:endParaRPr/>
           </a:p>
         </p:txBody>
       </p:sp>
@@ -13228,6 +13497,7 @@
           <a:lstStyle/>
           <a:p>
             <a:pPr algn="ctr"/>
+            <a:endParaRPr/>
           </a:p>
         </p:txBody>
       </p:sp>
@@ -13248,7 +13518,7 @@
           <a:noFill/>
         </p:spPr>
         <p:txBody>
-          <a:bodyPr wrap="square" lIns="36576" rIns="36576" tIns="36576" bIns="36576" anchor="t">
+          <a:bodyPr wrap="square" lIns="36576" tIns="36576" rIns="36576" bIns="36576" anchor="t">
             <a:spAutoFit/>
           </a:bodyPr>
           <a:lstStyle/>
@@ -13287,7 +13557,7 @@
           <a:noFill/>
         </p:spPr>
         <p:txBody>
-          <a:bodyPr wrap="square" lIns="36576" rIns="36576" tIns="36576" bIns="36576" anchor="t">
+          <a:bodyPr wrap="square" lIns="36576" tIns="36576" rIns="36576" bIns="36576" anchor="t">
             <a:spAutoFit/>
           </a:bodyPr>
           <a:lstStyle/>
@@ -13369,6 +13639,7 @@
           <a:lstStyle/>
           <a:p>
             <a:pPr algn="ctr"/>
+            <a:endParaRPr/>
           </a:p>
         </p:txBody>
       </p:sp>
@@ -13414,6 +13685,7 @@
           <a:lstStyle/>
           <a:p>
             <a:pPr algn="ctr"/>
+            <a:endParaRPr/>
           </a:p>
         </p:txBody>
       </p:sp>
@@ -13434,7 +13706,7 @@
           <a:noFill/>
         </p:spPr>
         <p:txBody>
-          <a:bodyPr wrap="square" lIns="36576" rIns="36576" tIns="36576" bIns="36576" anchor="t">
+          <a:bodyPr wrap="square" lIns="36576" tIns="36576" rIns="36576" bIns="36576" anchor="t">
             <a:spAutoFit/>
           </a:bodyPr>
           <a:lstStyle/>
@@ -13473,7 +13745,7 @@
           <a:noFill/>
         </p:spPr>
         <p:txBody>
-          <a:bodyPr wrap="square" lIns="36576" rIns="36576" tIns="36576" bIns="36576" anchor="t">
+          <a:bodyPr wrap="square" lIns="36576" tIns="36576" rIns="36576" bIns="36576" anchor="t">
             <a:spAutoFit/>
           </a:bodyPr>
           <a:lstStyle/>
@@ -13555,6 +13827,7 @@
           <a:lstStyle/>
           <a:p>
             <a:pPr algn="ctr"/>
+            <a:endParaRPr/>
           </a:p>
         </p:txBody>
       </p:sp>
@@ -13600,6 +13873,7 @@
           <a:lstStyle/>
           <a:p>
             <a:pPr algn="ctr"/>
+            <a:endParaRPr/>
           </a:p>
         </p:txBody>
       </p:sp>
@@ -13620,7 +13894,7 @@
           <a:noFill/>
         </p:spPr>
         <p:txBody>
-          <a:bodyPr wrap="square" lIns="36576" rIns="36576" tIns="36576" bIns="36576" anchor="t">
+          <a:bodyPr wrap="square" lIns="36576" tIns="36576" rIns="36576" bIns="36576" anchor="t">
             <a:spAutoFit/>
           </a:bodyPr>
           <a:lstStyle/>
@@ -13659,7 +13933,7 @@
           <a:noFill/>
         </p:spPr>
         <p:txBody>
-          <a:bodyPr wrap="square" lIns="36576" rIns="36576" tIns="36576" bIns="36576" anchor="t">
+          <a:bodyPr wrap="square" lIns="36576" tIns="36576" rIns="36576" bIns="36576" anchor="t">
             <a:spAutoFit/>
           </a:bodyPr>
           <a:lstStyle/>
@@ -13714,7 +13988,7 @@
           <a:noFill/>
         </p:spPr>
         <p:txBody>
-          <a:bodyPr wrap="square" lIns="36576" rIns="36576" tIns="36576" bIns="36576" anchor="t">
+          <a:bodyPr wrap="square" lIns="36576" tIns="36576" rIns="36576" bIns="36576" anchor="t">
             <a:spAutoFit/>
           </a:bodyPr>
           <a:lstStyle/>
@@ -13753,7 +14027,7 @@
           <a:noFill/>
         </p:spPr>
         <p:txBody>
-          <a:bodyPr wrap="square" lIns="36576" rIns="36576" tIns="36576" bIns="36576" anchor="t">
+          <a:bodyPr wrap="square" lIns="36576" tIns="36576" rIns="36576" bIns="36576" anchor="t">
             <a:spAutoFit/>
           </a:bodyPr>
           <a:lstStyle/>
@@ -13819,6 +14093,7 @@
           <a:lstStyle/>
           <a:p>
             <a:pPr algn="ctr"/>
+            <a:endParaRPr/>
           </a:p>
         </p:txBody>
       </p:sp>
@@ -13839,7 +14114,7 @@
           <a:noFill/>
         </p:spPr>
         <p:txBody>
-          <a:bodyPr wrap="square" lIns="36576" rIns="36576" tIns="36576" bIns="36576" anchor="t">
+          <a:bodyPr wrap="square" lIns="36576" tIns="36576" rIns="36576" bIns="36576" anchor="t">
             <a:spAutoFit/>
           </a:bodyPr>
           <a:lstStyle/>
@@ -13870,7 +14145,7 @@
 </file>
 
 <file path=ppt/slides/slide4.xml><?xml version="1.0" encoding="utf-8"?>
-<p:sld xmlns:a="http://schemas.openxmlformats.org/drawingml/2006/main" xmlns:p="http://schemas.openxmlformats.org/presentationml/2006/main" xmlns:r="http://schemas.openxmlformats.org/officeDocument/2006/relationships">
+<p:sld xmlns:a="http://schemas.openxmlformats.org/drawingml/2006/main" xmlns:r="http://schemas.openxmlformats.org/officeDocument/2006/relationships" xmlns:p="http://schemas.openxmlformats.org/presentationml/2006/main">
   <p:cSld>
     <p:bg>
       <p:bgPr>
@@ -13886,7 +14161,14 @@
         <p:cNvGrpSpPr/>
         <p:nvPr/>
       </p:nvGrpSpPr>
-      <p:grpSpPr/>
+      <p:grpSpPr>
+        <a:xfrm>
+          <a:off x="0" y="0"/>
+          <a:ext cx="0" cy="0"/>
+          <a:chOff x="0" y="0"/>
+          <a:chExt cx="0" cy="0"/>
+        </a:xfrm>
+      </p:grpSpPr>
       <p:sp>
         <p:nvSpPr>
           <p:cNvPr id="2" name="Rectangle 1"/>
@@ -13929,6 +14211,7 @@
           <a:lstStyle/>
           <a:p>
             <a:pPr algn="ctr"/>
+            <a:endParaRPr/>
           </a:p>
         </p:txBody>
       </p:sp>
@@ -13949,7 +14232,7 @@
           <a:noFill/>
         </p:spPr>
         <p:txBody>
-          <a:bodyPr wrap="square" lIns="36576" rIns="36576" tIns="36576" bIns="36576" anchor="t">
+          <a:bodyPr wrap="square" lIns="36576" tIns="36576" rIns="36576" bIns="36576" anchor="t">
             <a:spAutoFit/>
           </a:bodyPr>
           <a:lstStyle/>
@@ -13988,7 +14271,7 @@
           <a:noFill/>
         </p:spPr>
         <p:txBody>
-          <a:bodyPr wrap="square" lIns="36576" rIns="36576" tIns="36576" bIns="36576" anchor="t">
+          <a:bodyPr wrap="square" lIns="36576" tIns="36576" rIns="36576" bIns="36576" anchor="t">
             <a:spAutoFit/>
           </a:bodyPr>
           <a:lstStyle/>
@@ -14052,6 +14335,7 @@
           <a:lstStyle/>
           <a:p>
             <a:pPr algn="ctr"/>
+            <a:endParaRPr/>
           </a:p>
         </p:txBody>
       </p:sp>
@@ -14072,7 +14356,7 @@
           <a:noFill/>
         </p:spPr>
         <p:txBody>
-          <a:bodyPr wrap="square" lIns="36576" rIns="36576" tIns="36576" bIns="36576" anchor="t">
+          <a:bodyPr wrap="square" lIns="36576" tIns="36576" rIns="36576" bIns="36576" anchor="t">
             <a:spAutoFit/>
           </a:bodyPr>
           <a:lstStyle/>
@@ -14111,7 +14395,7 @@
           <a:noFill/>
         </p:spPr>
         <p:txBody>
-          <a:bodyPr wrap="square" lIns="36576" rIns="36576" tIns="36576" bIns="36576" anchor="t">
+          <a:bodyPr wrap="square" lIns="36576" tIns="36576" rIns="36576" bIns="36576" anchor="t">
             <a:spAutoFit/>
           </a:bodyPr>
           <a:lstStyle/>
@@ -14174,7 +14458,7 @@
           <a:noFill/>
         </p:spPr>
         <p:txBody>
-          <a:bodyPr wrap="square" lIns="36576" rIns="36576" tIns="36576" bIns="36576" anchor="t">
+          <a:bodyPr wrap="square" lIns="36576" tIns="36576" rIns="36576" bIns="36576" anchor="t">
             <a:spAutoFit/>
           </a:bodyPr>
           <a:lstStyle/>
@@ -14205,7 +14489,7 @@
 </file>
 
 <file path=ppt/slides/slide5.xml><?xml version="1.0" encoding="utf-8"?>
-<p:sld xmlns:a="http://schemas.openxmlformats.org/drawingml/2006/main" xmlns:p="http://schemas.openxmlformats.org/presentationml/2006/main" xmlns:r="http://schemas.openxmlformats.org/officeDocument/2006/relationships">
+<p:sld xmlns:a="http://schemas.openxmlformats.org/drawingml/2006/main" xmlns:r="http://schemas.openxmlformats.org/officeDocument/2006/relationships" xmlns:p="http://schemas.openxmlformats.org/presentationml/2006/main">
   <p:cSld>
     <p:bg>
       <p:bgPr>
@@ -14221,7 +14505,14 @@
         <p:cNvGrpSpPr/>
         <p:nvPr/>
       </p:nvGrpSpPr>
-      <p:grpSpPr/>
+      <p:grpSpPr>
+        <a:xfrm>
+          <a:off x="0" y="0"/>
+          <a:ext cx="0" cy="0"/>
+          <a:chOff x="0" y="0"/>
+          <a:chExt cx="0" cy="0"/>
+        </a:xfrm>
+      </p:grpSpPr>
       <p:sp>
         <p:nvSpPr>
           <p:cNvPr id="2" name="Rectangle 1"/>
@@ -14264,6 +14555,7 @@
           <a:lstStyle/>
           <a:p>
             <a:pPr algn="ctr"/>
+            <a:endParaRPr/>
           </a:p>
         </p:txBody>
       </p:sp>
@@ -14284,7 +14576,7 @@
           <a:noFill/>
         </p:spPr>
         <p:txBody>
-          <a:bodyPr wrap="square" lIns="36576" rIns="36576" tIns="36576" bIns="36576" anchor="t">
+          <a:bodyPr wrap="square" lIns="36576" tIns="36576" rIns="36576" bIns="36576" anchor="t">
             <a:spAutoFit/>
           </a:bodyPr>
           <a:lstStyle/>
@@ -14323,7 +14615,7 @@
           <a:noFill/>
         </p:spPr>
         <p:txBody>
-          <a:bodyPr wrap="square" lIns="36576" rIns="36576" tIns="36576" bIns="36576" anchor="t">
+          <a:bodyPr wrap="square" lIns="36576" tIns="36576" rIns="36576" bIns="36576" anchor="t">
             <a:spAutoFit/>
           </a:bodyPr>
           <a:lstStyle/>
@@ -14387,6 +14679,7 @@
           <a:lstStyle/>
           <a:p>
             <a:pPr algn="ctr"/>
+            <a:endParaRPr/>
           </a:p>
         </p:txBody>
       </p:sp>
@@ -14407,7 +14700,7 @@
           <a:noFill/>
         </p:spPr>
         <p:txBody>
-          <a:bodyPr wrap="square" lIns="36576" rIns="36576" tIns="36576" bIns="36576" anchor="t">
+          <a:bodyPr wrap="square" lIns="36576" tIns="36576" rIns="36576" bIns="36576" anchor="t">
             <a:spAutoFit/>
           </a:bodyPr>
           <a:lstStyle/>
@@ -14446,7 +14739,7 @@
           <a:noFill/>
         </p:spPr>
         <p:txBody>
-          <a:bodyPr wrap="square" lIns="36576" rIns="36576" tIns="36576" bIns="36576" anchor="t">
+          <a:bodyPr wrap="square" lIns="36576" tIns="36576" rIns="36576" bIns="36576" anchor="t">
             <a:spAutoFit/>
           </a:bodyPr>
           <a:lstStyle/>
@@ -14536,6 +14829,7 @@
           <a:lstStyle/>
           <a:p>
             <a:pPr algn="ctr"/>
+            <a:endParaRPr/>
           </a:p>
         </p:txBody>
       </p:sp>
@@ -14581,6 +14875,7 @@
           <a:lstStyle/>
           <a:p>
             <a:pPr algn="ctr"/>
+            <a:endParaRPr/>
           </a:p>
         </p:txBody>
       </p:sp>
@@ -14601,7 +14896,7 @@
           <a:noFill/>
         </p:spPr>
         <p:txBody>
-          <a:bodyPr wrap="square" lIns="36576" rIns="36576" tIns="36576" bIns="36576" anchor="t">
+          <a:bodyPr wrap="square" lIns="36576" tIns="36576" rIns="36576" bIns="36576" anchor="t">
             <a:spAutoFit/>
           </a:bodyPr>
           <a:lstStyle/>
@@ -14640,7 +14935,7 @@
           <a:noFill/>
         </p:spPr>
         <p:txBody>
-          <a:bodyPr wrap="square" lIns="36576" rIns="36576" tIns="36576" bIns="36576" anchor="t">
+          <a:bodyPr wrap="square" lIns="36576" tIns="36576" rIns="36576" bIns="36576" anchor="t">
             <a:spAutoFit/>
           </a:bodyPr>
           <a:lstStyle/>
@@ -14706,6 +15001,7 @@
           <a:lstStyle/>
           <a:p>
             <a:pPr algn="ctr"/>
+            <a:endParaRPr/>
           </a:p>
         </p:txBody>
       </p:sp>
@@ -14751,6 +15047,7 @@
           <a:lstStyle/>
           <a:p>
             <a:pPr algn="ctr"/>
+            <a:endParaRPr/>
           </a:p>
         </p:txBody>
       </p:sp>
@@ -14771,7 +15068,7 @@
           <a:noFill/>
         </p:spPr>
         <p:txBody>
-          <a:bodyPr wrap="square" lIns="36576" rIns="36576" tIns="36576" bIns="36576" anchor="t">
+          <a:bodyPr wrap="square" lIns="36576" tIns="36576" rIns="36576" bIns="36576" anchor="t">
             <a:spAutoFit/>
           </a:bodyPr>
           <a:lstStyle/>
@@ -14810,7 +15107,7 @@
           <a:noFill/>
         </p:spPr>
         <p:txBody>
-          <a:bodyPr wrap="square" lIns="36576" rIns="36576" tIns="36576" bIns="36576" anchor="t">
+          <a:bodyPr wrap="square" lIns="36576" tIns="36576" rIns="36576" bIns="36576" anchor="t">
             <a:spAutoFit/>
           </a:bodyPr>
           <a:lstStyle/>
@@ -14876,6 +15173,7 @@
           <a:lstStyle/>
           <a:p>
             <a:pPr algn="ctr"/>
+            <a:endParaRPr/>
           </a:p>
         </p:txBody>
       </p:sp>
@@ -14921,6 +15219,7 @@
           <a:lstStyle/>
           <a:p>
             <a:pPr algn="ctr"/>
+            <a:endParaRPr/>
           </a:p>
         </p:txBody>
       </p:sp>
@@ -14941,7 +15240,7 @@
           <a:noFill/>
         </p:spPr>
         <p:txBody>
-          <a:bodyPr wrap="square" lIns="36576" rIns="36576" tIns="36576" bIns="36576" anchor="t">
+          <a:bodyPr wrap="square" lIns="36576" tIns="36576" rIns="36576" bIns="36576" anchor="t">
             <a:spAutoFit/>
           </a:bodyPr>
           <a:lstStyle/>
@@ -14980,7 +15279,7 @@
           <a:noFill/>
         </p:spPr>
         <p:txBody>
-          <a:bodyPr wrap="square" lIns="36576" rIns="36576" tIns="36576" bIns="36576" anchor="t">
+          <a:bodyPr wrap="square" lIns="36576" tIns="36576" rIns="36576" bIns="36576" anchor="t">
             <a:spAutoFit/>
           </a:bodyPr>
           <a:lstStyle/>
@@ -15011,7 +15310,7 @@
 </file>
 
 <file path=ppt/slides/slide6.xml><?xml version="1.0" encoding="utf-8"?>
-<p:sld xmlns:a="http://schemas.openxmlformats.org/drawingml/2006/main" xmlns:p="http://schemas.openxmlformats.org/presentationml/2006/main" xmlns:r="http://schemas.openxmlformats.org/officeDocument/2006/relationships">
+<p:sld xmlns:a="http://schemas.openxmlformats.org/drawingml/2006/main" xmlns:r="http://schemas.openxmlformats.org/officeDocument/2006/relationships" xmlns:p="http://schemas.openxmlformats.org/presentationml/2006/main">
   <p:cSld>
     <p:bg>
       <p:bgPr>
@@ -15027,7 +15326,14 @@
         <p:cNvGrpSpPr/>
         <p:nvPr/>
       </p:nvGrpSpPr>
-      <p:grpSpPr/>
+      <p:grpSpPr>
+        <a:xfrm>
+          <a:off x="0" y="0"/>
+          <a:ext cx="0" cy="0"/>
+          <a:chOff x="0" y="0"/>
+          <a:chExt cx="0" cy="0"/>
+        </a:xfrm>
+      </p:grpSpPr>
       <p:sp>
         <p:nvSpPr>
           <p:cNvPr id="2" name="Rectangle 1"/>
@@ -15070,6 +15376,7 @@
           <a:lstStyle/>
           <a:p>
             <a:pPr algn="ctr"/>
+            <a:endParaRPr/>
           </a:p>
         </p:txBody>
       </p:sp>
@@ -15090,7 +15397,7 @@
           <a:noFill/>
         </p:spPr>
         <p:txBody>
-          <a:bodyPr wrap="square" lIns="36576" rIns="36576" tIns="36576" bIns="36576" anchor="t">
+          <a:bodyPr wrap="square" lIns="36576" tIns="36576" rIns="36576" bIns="36576" anchor="t">
             <a:spAutoFit/>
           </a:bodyPr>
           <a:lstStyle/>
@@ -15129,7 +15436,7 @@
           <a:noFill/>
         </p:spPr>
         <p:txBody>
-          <a:bodyPr wrap="square" lIns="36576" rIns="36576" tIns="36576" bIns="36576" anchor="t">
+          <a:bodyPr wrap="square" lIns="36576" tIns="36576" rIns="36576" bIns="36576" anchor="t">
             <a:spAutoFit/>
           </a:bodyPr>
           <a:lstStyle/>
@@ -15193,6 +15500,7 @@
           <a:lstStyle/>
           <a:p>
             <a:pPr algn="ctr"/>
+            <a:endParaRPr/>
           </a:p>
         </p:txBody>
       </p:sp>
@@ -15213,7 +15521,7 @@
           <a:noFill/>
         </p:spPr>
         <p:txBody>
-          <a:bodyPr wrap="square" lIns="36576" rIns="36576" tIns="36576" bIns="36576" anchor="t">
+          <a:bodyPr wrap="square" lIns="36576" tIns="36576" rIns="36576" bIns="36576" anchor="t">
             <a:spAutoFit/>
           </a:bodyPr>
           <a:lstStyle/>
@@ -15252,7 +15560,7 @@
           <a:noFill/>
         </p:spPr>
         <p:txBody>
-          <a:bodyPr wrap="square" lIns="36576" rIns="36576" tIns="36576" bIns="36576" anchor="t">
+          <a:bodyPr wrap="square" lIns="36576" tIns="36576" rIns="36576" bIns="36576" anchor="t">
             <a:spAutoFit/>
           </a:bodyPr>
           <a:lstStyle/>
@@ -15318,6 +15626,7 @@
           <a:lstStyle/>
           <a:p>
             <a:pPr algn="ctr"/>
+            <a:endParaRPr/>
           </a:p>
         </p:txBody>
       </p:sp>
@@ -15338,7 +15647,7 @@
           <a:noFill/>
         </p:spPr>
         <p:txBody>
-          <a:bodyPr wrap="square" lIns="36576" rIns="36576" tIns="36576" bIns="36576" anchor="t">
+          <a:bodyPr wrap="square" lIns="36576" tIns="36576" rIns="36576" bIns="36576" anchor="t">
             <a:spAutoFit/>
           </a:bodyPr>
           <a:lstStyle/>
@@ -15420,6 +15729,7 @@
           <a:lstStyle/>
           <a:p>
             <a:pPr algn="ctr"/>
+            <a:endParaRPr/>
           </a:p>
         </p:txBody>
       </p:sp>
@@ -15440,7 +15750,7 @@
           <a:noFill/>
         </p:spPr>
         <p:txBody>
-          <a:bodyPr wrap="square" lIns="36576" rIns="36576" tIns="36576" bIns="36576" anchor="t">
+          <a:bodyPr wrap="square" lIns="36576" tIns="36576" rIns="36576" bIns="36576" anchor="t">
             <a:spAutoFit/>
           </a:bodyPr>
           <a:lstStyle/>
@@ -15522,6 +15832,7 @@
           <a:lstStyle/>
           <a:p>
             <a:pPr algn="ctr"/>
+            <a:endParaRPr/>
           </a:p>
         </p:txBody>
       </p:sp>
@@ -15542,7 +15853,7 @@
           <a:noFill/>
         </p:spPr>
         <p:txBody>
-          <a:bodyPr wrap="square" lIns="36576" rIns="36576" tIns="36576" bIns="36576" anchor="t">
+          <a:bodyPr wrap="square" lIns="36576" tIns="36576" rIns="36576" bIns="36576" anchor="t">
             <a:spAutoFit/>
           </a:bodyPr>
           <a:lstStyle/>
@@ -15624,6 +15935,7 @@
           <a:lstStyle/>
           <a:p>
             <a:pPr algn="ctr"/>
+            <a:endParaRPr/>
           </a:p>
         </p:txBody>
       </p:sp>
@@ -15644,7 +15956,7 @@
           <a:noFill/>
         </p:spPr>
         <p:txBody>
-          <a:bodyPr wrap="square" lIns="36576" rIns="36576" tIns="36576" bIns="36576" anchor="t">
+          <a:bodyPr wrap="square" lIns="36576" tIns="36576" rIns="36576" bIns="36576" anchor="t">
             <a:spAutoFit/>
           </a:bodyPr>
           <a:lstStyle/>
@@ -15726,6 +16038,7 @@
           <a:lstStyle/>
           <a:p>
             <a:pPr algn="ctr"/>
+            <a:endParaRPr/>
           </a:p>
         </p:txBody>
       </p:sp>
@@ -15746,7 +16059,7 @@
           <a:noFill/>
         </p:spPr>
         <p:txBody>
-          <a:bodyPr wrap="square" lIns="36576" rIns="36576" tIns="36576" bIns="36576" anchor="t">
+          <a:bodyPr wrap="square" lIns="36576" tIns="36576" rIns="36576" bIns="36576" anchor="t">
             <a:spAutoFit/>
           </a:bodyPr>
           <a:lstStyle/>
@@ -15828,6 +16141,7 @@
           <a:lstStyle/>
           <a:p>
             <a:pPr algn="ctr"/>
+            <a:endParaRPr/>
           </a:p>
         </p:txBody>
       </p:sp>
@@ -15848,7 +16162,7 @@
           <a:noFill/>
         </p:spPr>
         <p:txBody>
-          <a:bodyPr wrap="square" lIns="36576" rIns="36576" tIns="36576" bIns="36576" anchor="t">
+          <a:bodyPr wrap="square" lIns="36576" tIns="36576" rIns="36576" bIns="36576" anchor="t">
             <a:spAutoFit/>
           </a:bodyPr>
           <a:lstStyle/>
@@ -16097,7 +16411,7 @@
           <a:noFill/>
         </p:spPr>
         <p:txBody>
-          <a:bodyPr wrap="square" lIns="36576" rIns="36576" tIns="36576" bIns="36576" anchor="t">
+          <a:bodyPr wrap="square" lIns="36576" tIns="36576" rIns="36576" bIns="36576" anchor="t">
             <a:spAutoFit/>
           </a:bodyPr>
           <a:lstStyle/>
@@ -16128,7 +16442,7 @@
 </file>
 
 <file path=ppt/slides/slide7.xml><?xml version="1.0" encoding="utf-8"?>
-<p:sld xmlns:a="http://schemas.openxmlformats.org/drawingml/2006/main" xmlns:p="http://schemas.openxmlformats.org/presentationml/2006/main" xmlns:r="http://schemas.openxmlformats.org/officeDocument/2006/relationships">
+<p:sld xmlns:a="http://schemas.openxmlformats.org/drawingml/2006/main" xmlns:r="http://schemas.openxmlformats.org/officeDocument/2006/relationships" xmlns:p="http://schemas.openxmlformats.org/presentationml/2006/main">
   <p:cSld>
     <p:bg>
       <p:bgPr>
@@ -16144,7 +16458,14 @@
         <p:cNvGrpSpPr/>
         <p:nvPr/>
       </p:nvGrpSpPr>
-      <p:grpSpPr/>
+      <p:grpSpPr>
+        <a:xfrm>
+          <a:off x="0" y="0"/>
+          <a:ext cx="0" cy="0"/>
+          <a:chOff x="0" y="0"/>
+          <a:chExt cx="0" cy="0"/>
+        </a:xfrm>
+      </p:grpSpPr>
       <p:sp>
         <p:nvSpPr>
           <p:cNvPr id="2" name="Rectangle 1"/>
@@ -16187,6 +16508,7 @@
           <a:lstStyle/>
           <a:p>
             <a:pPr algn="ctr"/>
+            <a:endParaRPr/>
           </a:p>
         </p:txBody>
       </p:sp>
@@ -16207,7 +16529,7 @@
           <a:noFill/>
         </p:spPr>
         <p:txBody>
-          <a:bodyPr wrap="square" lIns="36576" rIns="36576" tIns="36576" bIns="36576" anchor="t">
+          <a:bodyPr wrap="square" lIns="36576" tIns="36576" rIns="36576" bIns="36576" anchor="t">
             <a:spAutoFit/>
           </a:bodyPr>
           <a:lstStyle/>
@@ -16246,7 +16568,7 @@
           <a:noFill/>
         </p:spPr>
         <p:txBody>
-          <a:bodyPr wrap="square" lIns="36576" rIns="36576" tIns="36576" bIns="36576" anchor="t">
+          <a:bodyPr wrap="square" lIns="36576" tIns="36576" rIns="36576" bIns="36576" anchor="t">
             <a:spAutoFit/>
           </a:bodyPr>
           <a:lstStyle/>
@@ -16310,6 +16632,7 @@
           <a:lstStyle/>
           <a:p>
             <a:pPr algn="ctr"/>
+            <a:endParaRPr/>
           </a:p>
         </p:txBody>
       </p:sp>
@@ -16330,7 +16653,7 @@
           <a:noFill/>
         </p:spPr>
         <p:txBody>
-          <a:bodyPr wrap="square" lIns="36576" rIns="36576" tIns="36576" bIns="36576" anchor="t">
+          <a:bodyPr wrap="square" lIns="36576" tIns="36576" rIns="36576" bIns="36576" anchor="t">
             <a:spAutoFit/>
           </a:bodyPr>
           <a:lstStyle/>
@@ -16369,7 +16692,7 @@
           <a:noFill/>
         </p:spPr>
         <p:txBody>
-          <a:bodyPr wrap="square" lIns="36576" rIns="36576" tIns="36576" bIns="36576" anchor="t">
+          <a:bodyPr wrap="square" lIns="36576" tIns="36576" rIns="36576" bIns="36576" anchor="t">
             <a:spAutoFit/>
           </a:bodyPr>
           <a:lstStyle/>
@@ -16435,6 +16758,7 @@
           <a:lstStyle/>
           <a:p>
             <a:pPr algn="ctr"/>
+            <a:endParaRPr/>
           </a:p>
         </p:txBody>
       </p:sp>
@@ -16480,6 +16804,7 @@
           <a:lstStyle/>
           <a:p>
             <a:pPr algn="ctr"/>
+            <a:endParaRPr/>
           </a:p>
         </p:txBody>
       </p:sp>
@@ -16500,7 +16825,7 @@
           <a:noFill/>
         </p:spPr>
         <p:txBody>
-          <a:bodyPr wrap="square" lIns="36576" rIns="36576" tIns="36576" bIns="36576" anchor="t">
+          <a:bodyPr wrap="square" lIns="36576" tIns="36576" rIns="36576" bIns="36576" anchor="t">
             <a:spAutoFit/>
           </a:bodyPr>
           <a:lstStyle/>
@@ -16539,7 +16864,7 @@
           <a:noFill/>
         </p:spPr>
         <p:txBody>
-          <a:bodyPr wrap="square" lIns="36576" rIns="36576" tIns="36576" bIns="36576" anchor="t">
+          <a:bodyPr wrap="square" lIns="36576" tIns="36576" rIns="36576" bIns="36576" anchor="t">
             <a:spAutoFit/>
           </a:bodyPr>
           <a:lstStyle/>
@@ -16605,6 +16930,7 @@
           <a:lstStyle/>
           <a:p>
             <a:pPr algn="ctr"/>
+            <a:endParaRPr/>
           </a:p>
         </p:txBody>
       </p:sp>
@@ -16650,6 +16976,7 @@
           <a:lstStyle/>
           <a:p>
             <a:pPr algn="ctr"/>
+            <a:endParaRPr/>
           </a:p>
         </p:txBody>
       </p:sp>
@@ -16670,7 +16997,7 @@
           <a:noFill/>
         </p:spPr>
         <p:txBody>
-          <a:bodyPr wrap="square" lIns="36576" rIns="36576" tIns="36576" bIns="36576" anchor="t">
+          <a:bodyPr wrap="square" lIns="36576" tIns="36576" rIns="36576" bIns="36576" anchor="t">
             <a:spAutoFit/>
           </a:bodyPr>
           <a:lstStyle/>
@@ -16709,7 +17036,7 @@
           <a:noFill/>
         </p:spPr>
         <p:txBody>
-          <a:bodyPr wrap="square" lIns="36576" rIns="36576" tIns="36576" bIns="36576" anchor="t">
+          <a:bodyPr wrap="square" lIns="36576" tIns="36576" rIns="36576" bIns="36576" anchor="t">
             <a:spAutoFit/>
           </a:bodyPr>
           <a:lstStyle/>
@@ -16775,6 +17102,7 @@
           <a:lstStyle/>
           <a:p>
             <a:pPr algn="ctr"/>
+            <a:endParaRPr/>
           </a:p>
         </p:txBody>
       </p:sp>
@@ -16820,6 +17148,7 @@
           <a:lstStyle/>
           <a:p>
             <a:pPr algn="ctr"/>
+            <a:endParaRPr/>
           </a:p>
         </p:txBody>
       </p:sp>
@@ -16840,7 +17169,7 @@
           <a:noFill/>
         </p:spPr>
         <p:txBody>
-          <a:bodyPr wrap="square" lIns="36576" rIns="36576" tIns="36576" bIns="36576" anchor="t">
+          <a:bodyPr wrap="square" lIns="36576" tIns="36576" rIns="36576" bIns="36576" anchor="t">
             <a:spAutoFit/>
           </a:bodyPr>
           <a:lstStyle/>
@@ -16879,7 +17208,7 @@
           <a:noFill/>
         </p:spPr>
         <p:txBody>
-          <a:bodyPr wrap="square" lIns="36576" rIns="36576" tIns="36576" bIns="36576" anchor="t">
+          <a:bodyPr wrap="square" lIns="36576" tIns="36576" rIns="36576" bIns="36576" anchor="t">
             <a:spAutoFit/>
           </a:bodyPr>
           <a:lstStyle/>
@@ -16945,6 +17274,7 @@
           <a:lstStyle/>
           <a:p>
             <a:pPr algn="ctr"/>
+            <a:endParaRPr/>
           </a:p>
         </p:txBody>
       </p:sp>
@@ -16990,6 +17320,7 @@
           <a:lstStyle/>
           <a:p>
             <a:pPr algn="ctr"/>
+            <a:endParaRPr/>
           </a:p>
         </p:txBody>
       </p:sp>
@@ -17010,7 +17341,7 @@
           <a:noFill/>
         </p:spPr>
         <p:txBody>
-          <a:bodyPr wrap="square" lIns="36576" rIns="36576" tIns="36576" bIns="36576" anchor="t">
+          <a:bodyPr wrap="square" lIns="36576" tIns="36576" rIns="36576" bIns="36576" anchor="t">
             <a:spAutoFit/>
           </a:bodyPr>
           <a:lstStyle/>
@@ -17049,7 +17380,7 @@
           <a:noFill/>
         </p:spPr>
         <p:txBody>
-          <a:bodyPr wrap="square" lIns="36576" rIns="36576" tIns="36576" bIns="36576" anchor="t">
+          <a:bodyPr wrap="square" lIns="36576" tIns="36576" rIns="36576" bIns="36576" anchor="t">
             <a:spAutoFit/>
           </a:bodyPr>
           <a:lstStyle/>
@@ -17088,7 +17419,7 @@
           <a:noFill/>
         </p:spPr>
         <p:txBody>
-          <a:bodyPr wrap="square" lIns="36576" rIns="36576" tIns="36576" bIns="36576" anchor="t">
+          <a:bodyPr wrap="square" lIns="36576" tIns="36576" rIns="36576" bIns="36576" anchor="t">
             <a:spAutoFit/>
           </a:bodyPr>
           <a:lstStyle/>
@@ -17119,7 +17450,7 @@
 </file>
 
 <file path=ppt/slides/slide8.xml><?xml version="1.0" encoding="utf-8"?>
-<p:sld xmlns:a="http://schemas.openxmlformats.org/drawingml/2006/main" xmlns:p="http://schemas.openxmlformats.org/presentationml/2006/main" xmlns:r="http://schemas.openxmlformats.org/officeDocument/2006/relationships">
+<p:sld xmlns:a="http://schemas.openxmlformats.org/drawingml/2006/main" xmlns:r="http://schemas.openxmlformats.org/officeDocument/2006/relationships" xmlns:p="http://schemas.openxmlformats.org/presentationml/2006/main">
   <p:cSld>
     <p:bg>
       <p:bgPr>
@@ -17135,7 +17466,14 @@
         <p:cNvGrpSpPr/>
         <p:nvPr/>
       </p:nvGrpSpPr>
-      <p:grpSpPr/>
+      <p:grpSpPr>
+        <a:xfrm>
+          <a:off x="0" y="0"/>
+          <a:ext cx="0" cy="0"/>
+          <a:chOff x="0" y="0"/>
+          <a:chExt cx="0" cy="0"/>
+        </a:xfrm>
+      </p:grpSpPr>
       <p:sp>
         <p:nvSpPr>
           <p:cNvPr id="2" name="Rectangle 1"/>
@@ -17178,6 +17516,7 @@
           <a:lstStyle/>
           <a:p>
             <a:pPr algn="ctr"/>
+            <a:endParaRPr/>
           </a:p>
         </p:txBody>
       </p:sp>
@@ -17198,7 +17537,7 @@
           <a:noFill/>
         </p:spPr>
         <p:txBody>
-          <a:bodyPr wrap="square" lIns="36576" rIns="36576" tIns="36576" bIns="36576" anchor="t">
+          <a:bodyPr wrap="square" lIns="36576" tIns="36576" rIns="36576" bIns="36576" anchor="t">
             <a:spAutoFit/>
           </a:bodyPr>
           <a:lstStyle/>
@@ -17237,7 +17576,7 @@
           <a:noFill/>
         </p:spPr>
         <p:txBody>
-          <a:bodyPr wrap="square" lIns="36576" rIns="36576" tIns="36576" bIns="36576" anchor="t">
+          <a:bodyPr wrap="square" lIns="36576" tIns="36576" rIns="36576" bIns="36576" anchor="t">
             <a:spAutoFit/>
           </a:bodyPr>
           <a:lstStyle/>
@@ -17301,6 +17640,7 @@
           <a:lstStyle/>
           <a:p>
             <a:pPr algn="ctr"/>
+            <a:endParaRPr/>
           </a:p>
         </p:txBody>
       </p:sp>
@@ -17321,7 +17661,7 @@
           <a:noFill/>
         </p:spPr>
         <p:txBody>
-          <a:bodyPr wrap="square" lIns="36576" rIns="36576" tIns="36576" bIns="36576" anchor="t">
+          <a:bodyPr wrap="square" lIns="36576" tIns="36576" rIns="36576" bIns="36576" anchor="t">
             <a:spAutoFit/>
           </a:bodyPr>
           <a:lstStyle/>
@@ -17360,7 +17700,7 @@
           <a:noFill/>
         </p:spPr>
         <p:txBody>
-          <a:bodyPr wrap="square" lIns="36576" rIns="36576" tIns="36576" bIns="36576" anchor="t">
+          <a:bodyPr wrap="square" lIns="36576" tIns="36576" rIns="36576" bIns="36576" anchor="t">
             <a:spAutoFit/>
           </a:bodyPr>
           <a:lstStyle/>
@@ -17426,6 +17766,7 @@
           <a:lstStyle/>
           <a:p>
             <a:pPr algn="ctr"/>
+            <a:endParaRPr/>
           </a:p>
         </p:txBody>
       </p:sp>
@@ -17446,7 +17787,7 @@
           <a:noFill/>
         </p:spPr>
         <p:txBody>
-          <a:bodyPr wrap="square" lIns="36576" rIns="36576" tIns="36576" bIns="36576" anchor="t">
+          <a:bodyPr wrap="square" lIns="36576" tIns="36576" rIns="36576" bIns="36576" anchor="t">
             <a:spAutoFit/>
           </a:bodyPr>
           <a:lstStyle/>
@@ -17485,7 +17826,7 @@
           <a:noFill/>
         </p:spPr>
         <p:txBody>
-          <a:bodyPr wrap="square" lIns="36576" rIns="36576" tIns="36576" bIns="36576" anchor="t">
+          <a:bodyPr wrap="square" lIns="36576" tIns="36576" rIns="36576" bIns="36576" anchor="t">
             <a:spAutoFit/>
           </a:bodyPr>
           <a:lstStyle/>
@@ -17551,6 +17892,7 @@
           <a:lstStyle/>
           <a:p>
             <a:pPr algn="ctr"/>
+            <a:endParaRPr/>
           </a:p>
         </p:txBody>
       </p:sp>
@@ -17571,7 +17913,7 @@
           <a:noFill/>
         </p:spPr>
         <p:txBody>
-          <a:bodyPr wrap="square" lIns="36576" rIns="36576" tIns="36576" bIns="36576" anchor="t">
+          <a:bodyPr wrap="square" lIns="36576" tIns="36576" rIns="36576" bIns="36576" anchor="t">
             <a:spAutoFit/>
           </a:bodyPr>
           <a:lstStyle/>
@@ -17610,7 +17952,7 @@
           <a:noFill/>
         </p:spPr>
         <p:txBody>
-          <a:bodyPr wrap="square" lIns="36576" rIns="36576" tIns="36576" bIns="36576" anchor="t">
+          <a:bodyPr wrap="square" lIns="36576" tIns="36576" rIns="36576" bIns="36576" anchor="t">
             <a:spAutoFit/>
           </a:bodyPr>
           <a:lstStyle/>
@@ -17676,6 +18018,7 @@
           <a:lstStyle/>
           <a:p>
             <a:pPr algn="ctr"/>
+            <a:endParaRPr/>
           </a:p>
         </p:txBody>
       </p:sp>
@@ -17696,7 +18039,7 @@
           <a:noFill/>
         </p:spPr>
         <p:txBody>
-          <a:bodyPr wrap="square" lIns="36576" rIns="36576" tIns="36576" bIns="36576" anchor="t">
+          <a:bodyPr wrap="square" lIns="36576" tIns="36576" rIns="36576" bIns="36576" anchor="t">
             <a:spAutoFit/>
           </a:bodyPr>
           <a:lstStyle/>
@@ -17735,7 +18078,7 @@
           <a:noFill/>
         </p:spPr>
         <p:txBody>
-          <a:bodyPr wrap="square" lIns="36576" rIns="36576" tIns="36576" bIns="36576" anchor="t">
+          <a:bodyPr wrap="square" lIns="36576" tIns="36576" rIns="36576" bIns="36576" anchor="t">
             <a:spAutoFit/>
           </a:bodyPr>
           <a:lstStyle/>
@@ -17801,6 +18144,7 @@
           <a:lstStyle/>
           <a:p>
             <a:pPr algn="ctr"/>
+            <a:endParaRPr/>
           </a:p>
         </p:txBody>
       </p:sp>
@@ -17821,7 +18165,7 @@
           <a:noFill/>
         </p:spPr>
         <p:txBody>
-          <a:bodyPr wrap="square" lIns="36576" rIns="36576" tIns="36576" bIns="36576" anchor="t">
+          <a:bodyPr wrap="square" lIns="36576" tIns="36576" rIns="36576" bIns="36576" anchor="t">
             <a:spAutoFit/>
           </a:bodyPr>
           <a:lstStyle/>
@@ -17860,7 +18204,7 @@
           <a:noFill/>
         </p:spPr>
         <p:txBody>
-          <a:bodyPr wrap="square" lIns="36576" rIns="36576" tIns="36576" bIns="36576" anchor="t">
+          <a:bodyPr wrap="square" lIns="36576" tIns="36576" rIns="36576" bIns="36576" anchor="t">
             <a:spAutoFit/>
           </a:bodyPr>
           <a:lstStyle/>
@@ -17899,7 +18243,7 @@
           <a:noFill/>
         </p:spPr>
         <p:txBody>
-          <a:bodyPr wrap="square" lIns="36576" rIns="36576" tIns="36576" bIns="36576" anchor="t">
+          <a:bodyPr wrap="square" lIns="36576" tIns="36576" rIns="36576" bIns="36576" anchor="t">
             <a:spAutoFit/>
           </a:bodyPr>
           <a:lstStyle/>
@@ -17930,7 +18274,7 @@
 </file>
 
 <file path=ppt/slides/slide9.xml><?xml version="1.0" encoding="utf-8"?>
-<p:sld xmlns:a="http://schemas.openxmlformats.org/drawingml/2006/main" xmlns:p="http://schemas.openxmlformats.org/presentationml/2006/main" xmlns:r="http://schemas.openxmlformats.org/officeDocument/2006/relationships">
+<p:sld xmlns:a="http://schemas.openxmlformats.org/drawingml/2006/main" xmlns:r="http://schemas.openxmlformats.org/officeDocument/2006/relationships" xmlns:p="http://schemas.openxmlformats.org/presentationml/2006/main">
   <p:cSld>
     <p:bg>
       <p:bgPr>
@@ -17946,7 +18290,14 @@
         <p:cNvGrpSpPr/>
         <p:nvPr/>
       </p:nvGrpSpPr>
-      <p:grpSpPr/>
+      <p:grpSpPr>
+        <a:xfrm>
+          <a:off x="0" y="0"/>
+          <a:ext cx="0" cy="0"/>
+          <a:chOff x="0" y="0"/>
+          <a:chExt cx="0" cy="0"/>
+        </a:xfrm>
+      </p:grpSpPr>
       <p:sp>
         <p:nvSpPr>
           <p:cNvPr id="2" name="Rectangle 1"/>
@@ -17989,6 +18340,7 @@
           <a:lstStyle/>
           <a:p>
             <a:pPr algn="ctr"/>
+            <a:endParaRPr/>
           </a:p>
         </p:txBody>
       </p:sp>
@@ -18009,7 +18361,7 @@
           <a:noFill/>
         </p:spPr>
         <p:txBody>
-          <a:bodyPr wrap="square" lIns="36576" rIns="36576" tIns="36576" bIns="36576" anchor="t">
+          <a:bodyPr wrap="square" lIns="36576" tIns="36576" rIns="36576" bIns="36576" anchor="t">
             <a:spAutoFit/>
           </a:bodyPr>
           <a:lstStyle/>
@@ -18048,7 +18400,7 @@
           <a:noFill/>
         </p:spPr>
         <p:txBody>
-          <a:bodyPr wrap="square" lIns="36576" rIns="36576" tIns="36576" bIns="36576" anchor="t">
+          <a:bodyPr wrap="square" lIns="36576" tIns="36576" rIns="36576" bIns="36576" anchor="t">
             <a:spAutoFit/>
           </a:bodyPr>
           <a:lstStyle/>
@@ -18112,6 +18464,7 @@
           <a:lstStyle/>
           <a:p>
             <a:pPr algn="ctr"/>
+            <a:endParaRPr/>
           </a:p>
         </p:txBody>
       </p:sp>
@@ -18132,7 +18485,7 @@
           <a:noFill/>
         </p:spPr>
         <p:txBody>
-          <a:bodyPr wrap="square" lIns="36576" rIns="36576" tIns="36576" bIns="36576" anchor="t">
+          <a:bodyPr wrap="square" lIns="36576" tIns="36576" rIns="36576" bIns="36576" anchor="t">
             <a:spAutoFit/>
           </a:bodyPr>
           <a:lstStyle/>
@@ -18171,7 +18524,7 @@
           <a:noFill/>
         </p:spPr>
         <p:txBody>
-          <a:bodyPr wrap="square" lIns="36576" rIns="36576" tIns="36576" bIns="36576" anchor="t">
+          <a:bodyPr wrap="square" lIns="36576" tIns="36576" rIns="36576" bIns="36576" anchor="t">
             <a:spAutoFit/>
           </a:bodyPr>
           <a:lstStyle/>
@@ -18237,6 +18590,7 @@
           <a:lstStyle/>
           <a:p>
             <a:pPr algn="ctr"/>
+            <a:endParaRPr/>
           </a:p>
         </p:txBody>
       </p:sp>
@@ -18282,6 +18636,7 @@
           <a:lstStyle/>
           <a:p>
             <a:pPr algn="ctr"/>
+            <a:endParaRPr/>
           </a:p>
         </p:txBody>
       </p:sp>
@@ -18302,7 +18657,7 @@
           <a:noFill/>
         </p:spPr>
         <p:txBody>
-          <a:bodyPr wrap="square" lIns="36576" rIns="36576" tIns="36576" bIns="36576" anchor="t">
+          <a:bodyPr wrap="square" lIns="36576" tIns="36576" rIns="36576" bIns="36576" anchor="t">
             <a:spAutoFit/>
           </a:bodyPr>
           <a:lstStyle/>
@@ -18341,7 +18696,7 @@
           <a:noFill/>
         </p:spPr>
         <p:txBody>
-          <a:bodyPr wrap="square" lIns="36576" rIns="36576" tIns="36576" bIns="36576" anchor="t">
+          <a:bodyPr wrap="square" lIns="36576" tIns="36576" rIns="36576" bIns="36576" anchor="t">
             <a:spAutoFit/>
           </a:bodyPr>
           <a:lstStyle/>
@@ -18407,6 +18762,7 @@
           <a:lstStyle/>
           <a:p>
             <a:pPr algn="ctr"/>
+            <a:endParaRPr/>
           </a:p>
         </p:txBody>
       </p:sp>
@@ -18452,6 +18808,7 @@
           <a:lstStyle/>
           <a:p>
             <a:pPr algn="ctr"/>
+            <a:endParaRPr/>
           </a:p>
         </p:txBody>
       </p:sp>
@@ -18472,7 +18829,7 @@
           <a:noFill/>
         </p:spPr>
         <p:txBody>
-          <a:bodyPr wrap="square" lIns="36576" rIns="36576" tIns="36576" bIns="36576" anchor="t">
+          <a:bodyPr wrap="square" lIns="36576" tIns="36576" rIns="36576" bIns="36576" anchor="t">
             <a:spAutoFit/>
           </a:bodyPr>
           <a:lstStyle/>
@@ -18511,7 +18868,7 @@
           <a:noFill/>
         </p:spPr>
         <p:txBody>
-          <a:bodyPr wrap="square" lIns="36576" rIns="36576" tIns="36576" bIns="36576" anchor="t">
+          <a:bodyPr wrap="square" lIns="36576" tIns="36576" rIns="36576" bIns="36576" anchor="t">
             <a:spAutoFit/>
           </a:bodyPr>
           <a:lstStyle/>
@@ -18577,6 +18934,7 @@
           <a:lstStyle/>
           <a:p>
             <a:pPr algn="ctr"/>
+            <a:endParaRPr/>
           </a:p>
         </p:txBody>
       </p:sp>
@@ -18622,6 +18980,7 @@
           <a:lstStyle/>
           <a:p>
             <a:pPr algn="ctr"/>
+            <a:endParaRPr/>
           </a:p>
         </p:txBody>
       </p:sp>
@@ -18642,7 +19001,7 @@
           <a:noFill/>
         </p:spPr>
         <p:txBody>
-          <a:bodyPr wrap="square" lIns="36576" rIns="36576" tIns="36576" bIns="36576" anchor="t">
+          <a:bodyPr wrap="square" lIns="36576" tIns="36576" rIns="36576" bIns="36576" anchor="t">
             <a:spAutoFit/>
           </a:bodyPr>
           <a:lstStyle/>
@@ -18681,7 +19040,7 @@
           <a:noFill/>
         </p:spPr>
         <p:txBody>
-          <a:bodyPr wrap="square" lIns="36576" rIns="36576" tIns="36576" bIns="36576" anchor="t">
+          <a:bodyPr wrap="square" lIns="36576" tIns="36576" rIns="36576" bIns="36576" anchor="t">
             <a:spAutoFit/>
           </a:bodyPr>
           <a:lstStyle/>
@@ -18747,6 +19106,7 @@
           <a:lstStyle/>
           <a:p>
             <a:pPr algn="ctr"/>
+            <a:endParaRPr/>
           </a:p>
         </p:txBody>
       </p:sp>
@@ -18792,6 +19152,7 @@
           <a:lstStyle/>
           <a:p>
             <a:pPr algn="ctr"/>
+            <a:endParaRPr/>
           </a:p>
         </p:txBody>
       </p:sp>
@@ -18812,7 +19173,7 @@
           <a:noFill/>
         </p:spPr>
         <p:txBody>
-          <a:bodyPr wrap="square" lIns="36576" rIns="36576" tIns="36576" bIns="36576" anchor="t">
+          <a:bodyPr wrap="square" lIns="36576" tIns="36576" rIns="36576" bIns="36576" anchor="t">
             <a:spAutoFit/>
           </a:bodyPr>
           <a:lstStyle/>
@@ -18851,7 +19212,7 @@
           <a:noFill/>
         </p:spPr>
         <p:txBody>
-          <a:bodyPr wrap="square" lIns="36576" rIns="36576" tIns="36576" bIns="36576" anchor="t">
+          <a:bodyPr wrap="square" lIns="36576" tIns="36576" rIns="36576" bIns="36576" anchor="t">
             <a:spAutoFit/>
           </a:bodyPr>
           <a:lstStyle/>
@@ -18890,7 +19251,7 @@
           <a:noFill/>
         </p:spPr>
         <p:txBody>
-          <a:bodyPr wrap="square" lIns="36576" rIns="36576" tIns="36576" bIns="36576" anchor="t">
+          <a:bodyPr wrap="square" lIns="36576" tIns="36576" rIns="36576" bIns="36576" anchor="t">
             <a:spAutoFit/>
           </a:bodyPr>
           <a:lstStyle/>

</xml_diff>